<commit_message>
Archive des niveaux d'alerte du 2026-10-21
</commit_message>
<xml_diff>
--- a/web/rapports/GRSCI/2026-10.pptx
+++ b/web/rapports/GRSCI/2026-10.pptx
@@ -2437,34 +2437,34 @@
               <a:buNone/>
             </a:pPr>
             <a:r>
-              <a:rPr lang="en-US" sz="4000" b="1" dirty="0">
+              <a:rPr lang="en-US" sz="4400" dirty="0">
                 <a:solidFill>
                   <a:srgbClr val="FFFFFF"/>
                 </a:solidFill>
-                <a:latin typeface="Calibri" pitchFamily="34" charset="0"/>
-                <a:ea typeface="Calibri" pitchFamily="34" charset="-122"/>
-                <a:cs typeface="Calibri" pitchFamily="34" charset="-120"/>
+                <a:latin typeface="Arial Narrow" pitchFamily="34" charset="0"/>
+                <a:ea typeface="Arial Narrow" pitchFamily="34" charset="-122"/>
+                <a:cs typeface="Arial Narrow" pitchFamily="34" charset="-120"/>
               </a:rPr>
               <a:t>RENCONTRE MENSUELLE</a:t>
             </a:r>
-            <a:endParaRPr lang="en-US" sz="4000" dirty="0"/>
-          </a:p>
-          <a:p>
-            <a:pPr algn="ctr" indent="0" marL="0">
-              <a:buNone/>
-            </a:pPr>
-            <a:r>
-              <a:rPr lang="en-US" sz="4000" b="1" dirty="0">
+            <a:endParaRPr lang="en-US" sz="4400" dirty="0"/>
+          </a:p>
+          <a:p>
+            <a:pPr algn="ctr" indent="0" marL="0">
+              <a:buNone/>
+            </a:pPr>
+            <a:r>
+              <a:rPr lang="en-US" sz="4400" dirty="0">
                 <a:solidFill>
                   <a:srgbClr val="FFFFFF"/>
                 </a:solidFill>
-                <a:latin typeface="Calibri" pitchFamily="34" charset="0"/>
-                <a:ea typeface="Calibri" pitchFamily="34" charset="-122"/>
-                <a:cs typeface="Calibri" pitchFamily="34" charset="-120"/>
+                <a:latin typeface="Arial Narrow" pitchFamily="34" charset="0"/>
+                <a:ea typeface="Arial Narrow" pitchFamily="34" charset="-122"/>
+                <a:cs typeface="Arial Narrow" pitchFamily="34" charset="-120"/>
               </a:rPr>
               <a:t>G.R.S.CI</a:t>
             </a:r>
-            <a:endParaRPr lang="en-US" sz="4000" dirty="0"/>
+            <a:endParaRPr lang="en-US" sz="4400" dirty="0"/>
           </a:p>
         </p:txBody>
       </p:sp>
@@ -2838,17 +2838,17 @@
               <a:buNone/>
             </a:pPr>
             <a:r>
-              <a:rPr lang="en-US" sz="2200" b="1" dirty="0">
+              <a:rPr lang="en-US" sz="2400" dirty="0">
                 <a:solidFill>
                   <a:srgbClr val="FFFFFF"/>
                 </a:solidFill>
-                <a:latin typeface="Calibri" pitchFamily="34" charset="0"/>
-                <a:ea typeface="Calibri" pitchFamily="34" charset="-122"/>
-                <a:cs typeface="Calibri" pitchFamily="34" charset="-120"/>
+                <a:latin typeface="Arial Narrow" pitchFamily="34" charset="0"/>
+                <a:ea typeface="Arial Narrow" pitchFamily="34" charset="-122"/>
+                <a:cs typeface="Arial Narrow" pitchFamily="34" charset="-120"/>
               </a:rPr>
               <a:t>I</a:t>
             </a:r>
-            <a:endParaRPr lang="en-US" sz="2200" dirty="0"/>
+            <a:endParaRPr lang="en-US" sz="2400" dirty="0"/>
           </a:p>
         </p:txBody>
       </p:sp>
@@ -2877,13 +2877,13 @@
               <a:buNone/>
             </a:pPr>
             <a:r>
-              <a:rPr lang="en-US" sz="2800" b="1" dirty="0">
+              <a:rPr lang="en-US" sz="2800" u="sng" dirty="0">
                 <a:solidFill>
                   <a:srgbClr val="1F6B5E"/>
                 </a:solidFill>
-                <a:latin typeface="Calibri" pitchFamily="34" charset="0"/>
-                <a:ea typeface="Calibri" pitchFamily="34" charset="-122"/>
-                <a:cs typeface="Calibri" pitchFamily="34" charset="-120"/>
+                <a:latin typeface="Arial Narrow" pitchFamily="34" charset="0"/>
+                <a:ea typeface="Arial Narrow" pitchFamily="34" charset="-122"/>
+                <a:cs typeface="Arial Narrow" pitchFamily="34" charset="-120"/>
               </a:rPr>
               <a:t>Mali : situation au 21/10/26</a:t>
             </a:r>
@@ -2894,6 +2894,103 @@
       <p:sp>
         <p:nvSpPr>
           <p:cNvPr id="4" name="Shape 2"/>
+          <p:cNvSpPr/>
+          <p:nvPr/>
+        </p:nvSpPr>
+        <p:spPr>
+          <a:xfrm>
+            <a:off x="10881360" y="274320"/>
+            <a:ext cx="301752" cy="566928"/>
+          </a:xfrm>
+          <a:prstGeom prst="rect">
+            <a:avLst/>
+          </a:prstGeom>
+          <a:solidFill>
+            <a:srgbClr val="14B53A"/>
+          </a:solidFill>
+          <a:ln w="12700">
+            <a:solidFill>
+              <a:srgbClr val="14B53A"/>
+            </a:solidFill>
+            <a:prstDash val="solid"/>
+          </a:ln>
+        </p:spPr>
+      </p:sp>
+      <p:sp>
+        <p:nvSpPr>
+          <p:cNvPr id="5" name="Shape 3"/>
+          <p:cNvSpPr/>
+          <p:nvPr/>
+        </p:nvSpPr>
+        <p:spPr>
+          <a:xfrm>
+            <a:off x="11183112" y="274320"/>
+            <a:ext cx="301752" cy="566928"/>
+          </a:xfrm>
+          <a:prstGeom prst="rect">
+            <a:avLst/>
+          </a:prstGeom>
+          <a:solidFill>
+            <a:srgbClr val="FCD116"/>
+          </a:solidFill>
+          <a:ln w="12700">
+            <a:solidFill>
+              <a:srgbClr val="FCD116"/>
+            </a:solidFill>
+            <a:prstDash val="solid"/>
+          </a:ln>
+        </p:spPr>
+      </p:sp>
+      <p:sp>
+        <p:nvSpPr>
+          <p:cNvPr id="6" name="Shape 4"/>
+          <p:cNvSpPr/>
+          <p:nvPr/>
+        </p:nvSpPr>
+        <p:spPr>
+          <a:xfrm>
+            <a:off x="11484864" y="274320"/>
+            <a:ext cx="301752" cy="566928"/>
+          </a:xfrm>
+          <a:prstGeom prst="rect">
+            <a:avLst/>
+          </a:prstGeom>
+          <a:solidFill>
+            <a:srgbClr val="CE1126"/>
+          </a:solidFill>
+          <a:ln w="12700">
+            <a:solidFill>
+              <a:srgbClr val="CE1126"/>
+            </a:solidFill>
+            <a:prstDash val="solid"/>
+          </a:ln>
+        </p:spPr>
+      </p:sp>
+      <p:sp>
+        <p:nvSpPr>
+          <p:cNvPr id="7" name="Shape 5"/>
+          <p:cNvSpPr/>
+          <p:nvPr/>
+        </p:nvSpPr>
+        <p:spPr>
+          <a:xfrm>
+            <a:off x="10881360" y="274320"/>
+            <a:ext cx="905256" cy="566928"/>
+          </a:xfrm>
+          <a:prstGeom prst="rect">
+            <a:avLst/>
+          </a:prstGeom>
+          <a:ln w="6350">
+            <a:solidFill>
+              <a:srgbClr val="1F2937"/>
+            </a:solidFill>
+            <a:prstDash val="solid"/>
+          </a:ln>
+        </p:spPr>
+      </p:sp>
+      <p:sp>
+        <p:nvSpPr>
+          <p:cNvPr id="8" name="Shape 6"/>
           <p:cNvSpPr/>
           <p:nvPr/>
         </p:nvSpPr>
@@ -2916,7 +3013,7 @@
       </p:sp>
       <p:sp>
         <p:nvSpPr>
-          <p:cNvPr id="5" name="Text 3"/>
+          <p:cNvPr id="9" name="Text 7"/>
           <p:cNvSpPr/>
           <p:nvPr/>
         </p:nvSpPr>
@@ -2957,7 +3054,7 @@
       </p:sp>
       <p:sp>
         <p:nvSpPr>
-          <p:cNvPr id="6" name="Text 4"/>
+          <p:cNvPr id="10" name="Text 8"/>
           <p:cNvSpPr/>
           <p:nvPr/>
         </p:nvSpPr>
@@ -2992,7 +3089,7 @@
                 <a:ea typeface="Calibri" pitchFamily="34" charset="-122"/>
                 <a:cs typeface="Calibri" pitchFamily="34" charset="-120"/>
               </a:rPr>
-              <a:t>Massacre au Mali : l’État islamique s’attaque à la communauté idaksahak dans la région de Ménaka</a:t>
+              <a:t>Abyei : Alourdissement du bilan et tensions diplomatiques après une frappe aérienne dans la zone contestée</a:t>
             </a:r>
             <a:endParaRPr lang="en-US" sz="1300" dirty="0"/>
           </a:p>
@@ -3012,7 +3109,7 @@
                 <a:ea typeface="Calibri" pitchFamily="34" charset="-122"/>
                 <a:cs typeface="Calibri" pitchFamily="34" charset="-120"/>
               </a:rPr>
-              <a:t>Jeune Afrique · 20/10 16h UTC · niveau critique · Probable</a:t>
+              <a:t>Maliactu · 21/10 06h UTC · niveau critique · Probable</a:t>
             </a:r>
             <a:endParaRPr lang="en-US" sz="1300" dirty="0"/>
           </a:p>
@@ -3033,7 +3130,7 @@
                 <a:ea typeface="Calibri" pitchFamily="34" charset="-122"/>
                 <a:cs typeface="Calibri" pitchFamily="34" charset="-120"/>
               </a:rPr>
-              <a:t>Mali : une quarantaine de civils tuée dans un camp dans la région de Menaka</a:t>
+              <a:t>Massacre au Mali : l’État islamique s’attaque à la communauté idaksahak dans la région de Ménaka</a:t>
             </a:r>
             <a:endParaRPr lang="en-US" sz="1300" dirty="0"/>
           </a:p>
@@ -3053,7 +3150,7 @@
                 <a:ea typeface="Calibri" pitchFamily="34" charset="-122"/>
                 <a:cs typeface="Calibri" pitchFamily="34" charset="-120"/>
               </a:rPr>
-              <a:t>fr.saharamedias.net · 20/10 14h UTC · niveau critique · Non confirmé</a:t>
+              <a:t>Jeune Afrique · 20/10 16h UTC · niveau critique · Probable</a:t>
             </a:r>
             <a:endParaRPr lang="en-US" sz="1300" dirty="0"/>
           </a:p>
@@ -3074,7 +3171,7 @@
                 <a:ea typeface="Calibri" pitchFamily="34" charset="-122"/>
                 <a:cs typeface="Calibri" pitchFamily="34" charset="-120"/>
               </a:rPr>
-              <a:t>More than 40 civilians killed in Mali attack blamed on Islamic State</a:t>
+              <a:t>Mali : une quarantaine de civils tuée dans un camp dans la région de Menaka</a:t>
             </a:r>
             <a:endParaRPr lang="en-US" sz="1300" dirty="0"/>
           </a:p>
@@ -3094,7 +3191,7 @@
                 <a:ea typeface="Calibri" pitchFamily="34" charset="-122"/>
                 <a:cs typeface="Calibri" pitchFamily="34" charset="-120"/>
               </a:rPr>
-              <a:t>Africanews · 20/10 12h UTC · niveau critique · Probable</a:t>
+              <a:t>fr.saharamedias.net · 20/10 14h UTC · niveau critique · Non confirmé</a:t>
             </a:r>
             <a:endParaRPr lang="en-US" sz="1300" dirty="0"/>
           </a:p>
@@ -3115,7 +3212,7 @@
                 <a:ea typeface="Calibri" pitchFamily="34" charset="-122"/>
                 <a:cs typeface="Calibri" pitchFamily="34" charset="-120"/>
               </a:rPr>
-              <a:t>Défense et Sécurité : 678 jeunes soldats formés et présentés au drapeau à Koutiala</a:t>
+              <a:t>More than 40 civilians killed in Mali attack blamed on Islamic State</a:t>
             </a:r>
             <a:endParaRPr lang="en-US" sz="1300" dirty="0"/>
           </a:p>
@@ -3135,7 +3232,7 @@
                 <a:ea typeface="Calibri" pitchFamily="34" charset="-122"/>
                 <a:cs typeface="Calibri" pitchFamily="34" charset="-120"/>
               </a:rPr>
-              <a:t>Malijet · 20/10 09h UTC · niveau élevé · Probable</a:t>
+              <a:t>Africanews · 20/10 12h UTC · niveau critique · Probable</a:t>
             </a:r>
             <a:endParaRPr lang="en-US" sz="1300" dirty="0"/>
           </a:p>
@@ -3143,7 +3240,7 @@
       </p:sp>
       <p:sp>
         <p:nvSpPr>
-          <p:cNvPr id="7" name="Shape 5"/>
+          <p:cNvPr id="11" name="Shape 9"/>
           <p:cNvSpPr/>
           <p:nvPr/>
         </p:nvSpPr>
@@ -3168,7 +3265,7 @@
       </p:sp>
       <p:sp>
         <p:nvSpPr>
-          <p:cNvPr id="8" name="Text 6"/>
+          <p:cNvPr id="12" name="Text 10"/>
           <p:cNvSpPr/>
           <p:nvPr/>
         </p:nvSpPr>
@@ -3207,7 +3304,7 @@
       </p:sp>
       <p:sp>
         <p:nvSpPr>
-          <p:cNvPr id="9" name="Text 7"/>
+          <p:cNvPr id="13" name="Text 11"/>
           <p:cNvSpPr/>
           <p:nvPr/>
         </p:nvSpPr>
@@ -3242,7 +3339,7 @@
                 <a:ea typeface="Calibri" pitchFamily="34" charset="-122"/>
                 <a:cs typeface="Calibri" pitchFamily="34" charset="-120"/>
               </a:rPr>
-              <a:t>Niveau rouge (grave, 84.7/100), confiance moyenne.</a:t>
+              <a:t>Niveau rouge (grave, 84.7/100), confiance faible.</a:t>
             </a:r>
             <a:endParaRPr lang="en-US" sz="1200" dirty="0"/>
           </a:p>
@@ -3263,7 +3360,7 @@
                 <a:ea typeface="Calibri" pitchFamily="34" charset="-122"/>
                 <a:cs typeface="Calibri" pitchFamily="34" charset="-120"/>
               </a:rPr>
-              <a:t>Fondement : incident vérifié le plus récent : 114 jours ; 2 signaux du jour.</a:t>
+              <a:t>Fondement : incident vérifié le plus récent : 114 jours ; aucun signal du jour.</a:t>
             </a:r>
             <a:endParaRPr lang="en-US" sz="1200" dirty="0"/>
           </a:p>
@@ -3305,7 +3402,7 @@
                 <a:ea typeface="Calibri" pitchFamily="34" charset="-122"/>
                 <a:cs typeface="Calibri" pitchFamily="34" charset="-120"/>
               </a:rPr>
-              <a:t>12 fait(s) au-dessus du normal dans les 36 dernières heures.</a:t>
+              <a:t>9 fait(s) au-dessus du normal dans les 36 dernières heures.</a:t>
             </a:r>
             <a:endParaRPr lang="en-US" sz="1200" dirty="0"/>
           </a:p>
@@ -3313,7 +3410,7 @@
       </p:sp>
       <p:pic>
         <p:nvPicPr>
-          <p:cNvPr id="10" name="Image 0" descr="/home/runner/work/SentiqS/SentiqS/scripts/assets/grsci/logo-grsci.png">    </p:cNvPr>
+          <p:cNvPr id="14" name="Image 0" descr="/home/runner/work/SentiqS/SentiqS/scripts/assets/grsci/logo-grsci.png">    </p:cNvPr>
           <p:cNvPicPr>
             <a:picLocks noChangeAspect="1"/>
           </p:cNvPicPr>
@@ -3337,7 +3434,7 @@
       </p:pic>
       <p:sp>
         <p:nvSpPr>
-          <p:cNvPr id="11" name="Text 8"/>
+          <p:cNvPr id="15" name="Text 12"/>
           <p:cNvSpPr/>
           <p:nvPr/>
         </p:nvSpPr>
@@ -3506,7 +3603,7 @@
       </p:sp>
       <p:sp>
         <p:nvSpPr>
-          <p:cNvPr id="12" name="Text 9"/>
+          <p:cNvPr id="16" name="Text 13"/>
           <p:cNvSpPr/>
           <p:nvPr/>
         </p:nvSpPr>
@@ -3595,17 +3692,17 @@
               <a:buNone/>
             </a:pPr>
             <a:r>
-              <a:rPr lang="en-US" sz="2200" b="1" dirty="0">
+              <a:rPr lang="en-US" sz="2400" dirty="0">
                 <a:solidFill>
                   <a:srgbClr val="FFFFFF"/>
                 </a:solidFill>
-                <a:latin typeface="Calibri" pitchFamily="34" charset="0"/>
-                <a:ea typeface="Calibri" pitchFamily="34" charset="-122"/>
-                <a:cs typeface="Calibri" pitchFamily="34" charset="-120"/>
+                <a:latin typeface="Arial Narrow" pitchFamily="34" charset="0"/>
+                <a:ea typeface="Arial Narrow" pitchFamily="34" charset="-122"/>
+                <a:cs typeface="Arial Narrow" pitchFamily="34" charset="-120"/>
               </a:rPr>
               <a:t>I</a:t>
             </a:r>
-            <a:endParaRPr lang="en-US" sz="2200" dirty="0"/>
+            <a:endParaRPr lang="en-US" sz="2400" dirty="0"/>
           </a:p>
         </p:txBody>
       </p:sp>
@@ -3634,13 +3731,13 @@
               <a:buNone/>
             </a:pPr>
             <a:r>
-              <a:rPr lang="en-US" sz="2800" b="1" dirty="0">
+              <a:rPr lang="en-US" sz="2800" u="sng" dirty="0">
                 <a:solidFill>
                   <a:srgbClr val="1F6B5E"/>
                 </a:solidFill>
-                <a:latin typeface="Calibri" pitchFamily="34" charset="0"/>
-                <a:ea typeface="Calibri" pitchFamily="34" charset="-122"/>
-                <a:cs typeface="Calibri" pitchFamily="34" charset="-120"/>
+                <a:latin typeface="Arial Narrow" pitchFamily="34" charset="0"/>
+                <a:ea typeface="Arial Narrow" pitchFamily="34" charset="-122"/>
+                <a:cs typeface="Arial Narrow" pitchFamily="34" charset="-120"/>
               </a:rPr>
               <a:t>Niger : situation au 21/10/26</a:t>
             </a:r>
@@ -3651,6 +3748,103 @@
       <p:sp>
         <p:nvSpPr>
           <p:cNvPr id="4" name="Shape 2"/>
+          <p:cNvSpPr/>
+          <p:nvPr/>
+        </p:nvSpPr>
+        <p:spPr>
+          <a:xfrm>
+            <a:off x="10881360" y="274320"/>
+            <a:ext cx="905256" cy="188976"/>
+          </a:xfrm>
+          <a:prstGeom prst="rect">
+            <a:avLst/>
+          </a:prstGeom>
+          <a:solidFill>
+            <a:srgbClr val="E05206"/>
+          </a:solidFill>
+          <a:ln w="12700">
+            <a:solidFill>
+              <a:srgbClr val="E05206"/>
+            </a:solidFill>
+            <a:prstDash val="solid"/>
+          </a:ln>
+        </p:spPr>
+      </p:sp>
+      <p:sp>
+        <p:nvSpPr>
+          <p:cNvPr id="5" name="Shape 3"/>
+          <p:cNvSpPr/>
+          <p:nvPr/>
+        </p:nvSpPr>
+        <p:spPr>
+          <a:xfrm>
+            <a:off x="10881360" y="463296"/>
+            <a:ext cx="905256" cy="188976"/>
+          </a:xfrm>
+          <a:prstGeom prst="rect">
+            <a:avLst/>
+          </a:prstGeom>
+          <a:solidFill>
+            <a:srgbClr val="FFFFFF"/>
+          </a:solidFill>
+          <a:ln w="12700">
+            <a:solidFill>
+              <a:srgbClr val="FFFFFF"/>
+            </a:solidFill>
+            <a:prstDash val="solid"/>
+          </a:ln>
+        </p:spPr>
+      </p:sp>
+      <p:sp>
+        <p:nvSpPr>
+          <p:cNvPr id="6" name="Shape 4"/>
+          <p:cNvSpPr/>
+          <p:nvPr/>
+        </p:nvSpPr>
+        <p:spPr>
+          <a:xfrm>
+            <a:off x="10881360" y="652272"/>
+            <a:ext cx="905256" cy="188976"/>
+          </a:xfrm>
+          <a:prstGeom prst="rect">
+            <a:avLst/>
+          </a:prstGeom>
+          <a:solidFill>
+            <a:srgbClr val="0DB02B"/>
+          </a:solidFill>
+          <a:ln w="12700">
+            <a:solidFill>
+              <a:srgbClr val="0DB02B"/>
+            </a:solidFill>
+            <a:prstDash val="solid"/>
+          </a:ln>
+        </p:spPr>
+      </p:sp>
+      <p:sp>
+        <p:nvSpPr>
+          <p:cNvPr id="7" name="Shape 5"/>
+          <p:cNvSpPr/>
+          <p:nvPr/>
+        </p:nvSpPr>
+        <p:spPr>
+          <a:xfrm>
+            <a:off x="10881360" y="274320"/>
+            <a:ext cx="905256" cy="566928"/>
+          </a:xfrm>
+          <a:prstGeom prst="rect">
+            <a:avLst/>
+          </a:prstGeom>
+          <a:ln w="6350">
+            <a:solidFill>
+              <a:srgbClr val="1F2937"/>
+            </a:solidFill>
+            <a:prstDash val="solid"/>
+          </a:ln>
+        </p:spPr>
+      </p:sp>
+      <p:sp>
+        <p:nvSpPr>
+          <p:cNvPr id="8" name="Shape 6"/>
           <p:cNvSpPr/>
           <p:nvPr/>
         </p:nvSpPr>
@@ -3673,7 +3867,7 @@
       </p:sp>
       <p:sp>
         <p:nvSpPr>
-          <p:cNvPr id="5" name="Text 3"/>
+          <p:cNvPr id="9" name="Text 7"/>
           <p:cNvSpPr/>
           <p:nvPr/>
         </p:nvSpPr>
@@ -3714,7 +3908,7 @@
       </p:sp>
       <p:sp>
         <p:nvSpPr>
-          <p:cNvPr id="6" name="Text 4"/>
+          <p:cNvPr id="10" name="Text 8"/>
           <p:cNvSpPr/>
           <p:nvPr/>
         </p:nvSpPr>
@@ -3773,52 +3967,11 @@
             </a:r>
             <a:endParaRPr lang="en-US" sz="1300" dirty="0"/>
           </a:p>
-          <a:p>
-            <a:pPr marL="342900" indent="-342900">
-              <a:spcAft>
-                <a:spcPts val="300"/>
-              </a:spcAft>
-              <a:buSzPct val="100000"/>
-              <a:buChar char="✓"/>
-            </a:pPr>
-            <a:r>
-              <a:rPr lang="en-US" sz="1300" b="1" dirty="0">
-                <a:solidFill>
-                  <a:srgbClr val="1F2937"/>
-                </a:solidFill>
-                <a:latin typeface="Calibri" pitchFamily="34" charset="0"/>
-                <a:ea typeface="Calibri" pitchFamily="34" charset="-122"/>
-                <a:cs typeface="Calibri" pitchFamily="34" charset="-120"/>
-              </a:rPr>
-              <a:t>OCRTIS, un rempart contre la drogue et la criminalité au Niger…</a:t>
-            </a:r>
-            <a:endParaRPr lang="en-US" sz="1300" dirty="0"/>
-          </a:p>
-          <a:p>
-            <a:pPr lvl="1" indent="0" marL="0">
-              <a:spcAft>
-                <a:spcPts val="300"/>
-              </a:spcAft>
-              <a:buNone/>
-            </a:pPr>
-            <a:r>
-              <a:rPr lang="en-US" sz="1100" i="1" dirty="0">
-                <a:solidFill>
-                  <a:srgbClr val="6B7280"/>
-                </a:solidFill>
-                <a:latin typeface="Calibri" pitchFamily="34" charset="0"/>
-                <a:ea typeface="Calibri" pitchFamily="34" charset="-122"/>
-                <a:cs typeface="Calibri" pitchFamily="34" charset="-120"/>
-              </a:rPr>
-              <a:t>Tamtaminfo · 19/10 18h UTC · niveau élevé · Non confirmé</a:t>
-            </a:r>
-            <a:endParaRPr lang="en-US" sz="1300" dirty="0"/>
-          </a:p>
         </p:txBody>
       </p:sp>
       <p:sp>
         <p:nvSpPr>
-          <p:cNvPr id="7" name="Shape 5"/>
+          <p:cNvPr id="11" name="Shape 9"/>
           <p:cNvSpPr/>
           <p:nvPr/>
         </p:nvSpPr>
@@ -3843,7 +3996,7 @@
       </p:sp>
       <p:sp>
         <p:nvSpPr>
-          <p:cNvPr id="8" name="Text 6"/>
+          <p:cNvPr id="12" name="Text 10"/>
           <p:cNvSpPr/>
           <p:nvPr/>
         </p:nvSpPr>
@@ -3882,7 +4035,7 @@
       </p:sp>
       <p:sp>
         <p:nvSpPr>
-          <p:cNvPr id="9" name="Text 7"/>
+          <p:cNvPr id="13" name="Text 11"/>
           <p:cNvSpPr/>
           <p:nvPr/>
         </p:nvSpPr>
@@ -4001,7 +4154,7 @@
                 <a:ea typeface="Calibri" pitchFamily="34" charset="-122"/>
                 <a:cs typeface="Calibri" pitchFamily="34" charset="-120"/>
               </a:rPr>
-              <a:t>2 fait(s) au-dessus du normal dans les 36 dernières heures.</a:t>
+              <a:t>1 fait(s) au-dessus du normal dans les 36 dernières heures.</a:t>
             </a:r>
             <a:endParaRPr lang="en-US" sz="1200" dirty="0"/>
           </a:p>
@@ -4009,7 +4162,7 @@
       </p:sp>
       <p:pic>
         <p:nvPicPr>
-          <p:cNvPr id="10" name="Image 0" descr="/home/runner/work/SentiqS/SentiqS/scripts/assets/grsci/logo-grsci.png">    </p:cNvPr>
+          <p:cNvPr id="14" name="Image 0" descr="/home/runner/work/SentiqS/SentiqS/scripts/assets/grsci/logo-grsci.png">    </p:cNvPr>
           <p:cNvPicPr>
             <a:picLocks noChangeAspect="1"/>
           </p:cNvPicPr>
@@ -4033,7 +4186,7 @@
       </p:pic>
       <p:sp>
         <p:nvSpPr>
-          <p:cNvPr id="11" name="Text 8"/>
+          <p:cNvPr id="15" name="Text 12"/>
           <p:cNvSpPr/>
           <p:nvPr/>
         </p:nvSpPr>
@@ -4202,7 +4355,7 @@
       </p:sp>
       <p:sp>
         <p:nvSpPr>
-          <p:cNvPr id="12" name="Text 9"/>
+          <p:cNvPr id="16" name="Text 13"/>
           <p:cNvSpPr/>
           <p:nvPr/>
         </p:nvSpPr>
@@ -4291,17 +4444,17 @@
               <a:buNone/>
             </a:pPr>
             <a:r>
-              <a:rPr lang="en-US" sz="2200" b="1" dirty="0">
+              <a:rPr lang="en-US" sz="2400" dirty="0">
                 <a:solidFill>
                   <a:srgbClr val="FFFFFF"/>
                 </a:solidFill>
-                <a:latin typeface="Calibri" pitchFamily="34" charset="0"/>
-                <a:ea typeface="Calibri" pitchFamily="34" charset="-122"/>
-                <a:cs typeface="Calibri" pitchFamily="34" charset="-120"/>
+                <a:latin typeface="Arial Narrow" pitchFamily="34" charset="0"/>
+                <a:ea typeface="Arial Narrow" pitchFamily="34" charset="-122"/>
+                <a:cs typeface="Arial Narrow" pitchFamily="34" charset="-120"/>
               </a:rPr>
               <a:t>I</a:t>
             </a:r>
-            <a:endParaRPr lang="en-US" sz="2200" dirty="0"/>
+            <a:endParaRPr lang="en-US" sz="2400" dirty="0"/>
           </a:p>
         </p:txBody>
       </p:sp>
@@ -4330,13 +4483,13 @@
               <a:buNone/>
             </a:pPr>
             <a:r>
-              <a:rPr lang="en-US" sz="2800" b="1" dirty="0">
+              <a:rPr lang="en-US" sz="2800" u="sng" dirty="0">
                 <a:solidFill>
                   <a:srgbClr val="1F6B5E"/>
                 </a:solidFill>
-                <a:latin typeface="Calibri" pitchFamily="34" charset="0"/>
-                <a:ea typeface="Calibri" pitchFamily="34" charset="-122"/>
-                <a:cs typeface="Calibri" pitchFamily="34" charset="-120"/>
+                <a:latin typeface="Arial Narrow" pitchFamily="34" charset="0"/>
+                <a:ea typeface="Arial Narrow" pitchFamily="34" charset="-122"/>
+                <a:cs typeface="Arial Narrow" pitchFamily="34" charset="-120"/>
               </a:rPr>
               <a:t>Ghana : situation au 21/10/26</a:t>
             </a:r>
@@ -4347,6 +4500,103 @@
       <p:sp>
         <p:nvSpPr>
           <p:cNvPr id="4" name="Shape 2"/>
+          <p:cNvSpPr/>
+          <p:nvPr/>
+        </p:nvSpPr>
+        <p:spPr>
+          <a:xfrm>
+            <a:off x="10881360" y="274320"/>
+            <a:ext cx="905256" cy="188976"/>
+          </a:xfrm>
+          <a:prstGeom prst="rect">
+            <a:avLst/>
+          </a:prstGeom>
+          <a:solidFill>
+            <a:srgbClr val="CE1126"/>
+          </a:solidFill>
+          <a:ln w="12700">
+            <a:solidFill>
+              <a:srgbClr val="CE1126"/>
+            </a:solidFill>
+            <a:prstDash val="solid"/>
+          </a:ln>
+        </p:spPr>
+      </p:sp>
+      <p:sp>
+        <p:nvSpPr>
+          <p:cNvPr id="5" name="Shape 3"/>
+          <p:cNvSpPr/>
+          <p:nvPr/>
+        </p:nvSpPr>
+        <p:spPr>
+          <a:xfrm>
+            <a:off x="10881360" y="463296"/>
+            <a:ext cx="905256" cy="188976"/>
+          </a:xfrm>
+          <a:prstGeom prst="rect">
+            <a:avLst/>
+          </a:prstGeom>
+          <a:solidFill>
+            <a:srgbClr val="FCD116"/>
+          </a:solidFill>
+          <a:ln w="12700">
+            <a:solidFill>
+              <a:srgbClr val="FCD116"/>
+            </a:solidFill>
+            <a:prstDash val="solid"/>
+          </a:ln>
+        </p:spPr>
+      </p:sp>
+      <p:sp>
+        <p:nvSpPr>
+          <p:cNvPr id="6" name="Shape 4"/>
+          <p:cNvSpPr/>
+          <p:nvPr/>
+        </p:nvSpPr>
+        <p:spPr>
+          <a:xfrm>
+            <a:off x="10881360" y="652272"/>
+            <a:ext cx="905256" cy="188976"/>
+          </a:xfrm>
+          <a:prstGeom prst="rect">
+            <a:avLst/>
+          </a:prstGeom>
+          <a:solidFill>
+            <a:srgbClr val="006B3F"/>
+          </a:solidFill>
+          <a:ln w="12700">
+            <a:solidFill>
+              <a:srgbClr val="006B3F"/>
+            </a:solidFill>
+            <a:prstDash val="solid"/>
+          </a:ln>
+        </p:spPr>
+      </p:sp>
+      <p:sp>
+        <p:nvSpPr>
+          <p:cNvPr id="7" name="Shape 5"/>
+          <p:cNvSpPr/>
+          <p:nvPr/>
+        </p:nvSpPr>
+        <p:spPr>
+          <a:xfrm>
+            <a:off x="10881360" y="274320"/>
+            <a:ext cx="905256" cy="566928"/>
+          </a:xfrm>
+          <a:prstGeom prst="rect">
+            <a:avLst/>
+          </a:prstGeom>
+          <a:ln w="6350">
+            <a:solidFill>
+              <a:srgbClr val="1F2937"/>
+            </a:solidFill>
+            <a:prstDash val="solid"/>
+          </a:ln>
+        </p:spPr>
+      </p:sp>
+      <p:sp>
+        <p:nvSpPr>
+          <p:cNvPr id="8" name="Shape 6"/>
           <p:cNvSpPr/>
           <p:nvPr/>
         </p:nvSpPr>
@@ -4369,7 +4619,7 @@
       </p:sp>
       <p:sp>
         <p:nvSpPr>
-          <p:cNvPr id="5" name="Text 3"/>
+          <p:cNvPr id="9" name="Text 7"/>
           <p:cNvSpPr/>
           <p:nvPr/>
         </p:nvSpPr>
@@ -4410,7 +4660,7 @@
       </p:sp>
       <p:sp>
         <p:nvSpPr>
-          <p:cNvPr id="6" name="Text 4"/>
+          <p:cNvPr id="10" name="Text 8"/>
           <p:cNvSpPr/>
           <p:nvPr/>
         </p:nvSpPr>
@@ -4445,7 +4695,7 @@
                 <a:ea typeface="Calibri" pitchFamily="34" charset="-122"/>
                 <a:cs typeface="Calibri" pitchFamily="34" charset="-120"/>
               </a:rPr>
-              <a:t>ECG to begin nationwide meter audit exercise</a:t>
+              <a:t>Four pupils killed as van crashes into children in Aboabo</a:t>
             </a:r>
             <a:endParaRPr lang="en-US" sz="1300" dirty="0"/>
           </a:p>
@@ -4465,15 +4715,56 @@
                 <a:ea typeface="Calibri" pitchFamily="34" charset="-122"/>
                 <a:cs typeface="Calibri" pitchFamily="34" charset="-120"/>
               </a:rPr>
-              <a:t>Ghanaian Times · 20/10 14h UTC · niveau modéré · Non confirmé</a:t>
+              <a:t>JoyOnline · 21/10 06h UTC · niveau critique · Probable</a:t>
             </a:r>
             <a:endParaRPr lang="en-US" sz="1300" dirty="0"/>
           </a:p>
+          <a:p>
+            <a:pPr marL="342900" indent="-342900">
+              <a:spcAft>
+                <a:spcPts val="300"/>
+              </a:spcAft>
+              <a:buSzPct val="100000"/>
+              <a:buChar char="✓"/>
+            </a:pPr>
+            <a:r>
+              <a:rPr lang="en-US" sz="1300" b="1" dirty="0">
+                <a:solidFill>
+                  <a:srgbClr val="1F2937"/>
+                </a:solidFill>
+                <a:latin typeface="Calibri" pitchFamily="34" charset="0"/>
+                <a:ea typeface="Calibri" pitchFamily="34" charset="-122"/>
+                <a:cs typeface="Calibri" pitchFamily="34" charset="-120"/>
+              </a:rPr>
+              <a:t>Women groups condemn Obuasi SHTS sexual abuse scandal</a:t>
+            </a:r>
+            <a:endParaRPr lang="en-US" sz="1300" dirty="0"/>
+          </a:p>
+          <a:p>
+            <a:pPr lvl="1" indent="0" marL="0">
+              <a:spcAft>
+                <a:spcPts val="300"/>
+              </a:spcAft>
+              <a:buNone/>
+            </a:pPr>
+            <a:r>
+              <a:rPr lang="en-US" sz="1100" i="1" dirty="0">
+                <a:solidFill>
+                  <a:srgbClr val="6B7280"/>
+                </a:solidFill>
+                <a:latin typeface="Calibri" pitchFamily="34" charset="0"/>
+                <a:ea typeface="Calibri" pitchFamily="34" charset="-122"/>
+                <a:cs typeface="Calibri" pitchFamily="34" charset="-120"/>
+              </a:rPr>
+              <a:t>Ghana Business News · 21/10 06h UTC · niveau modéré · Non confirmé</a:t>
+            </a:r>
+            <a:endParaRPr lang="en-US" sz="1300" dirty="0"/>
+          </a:p>
         </p:txBody>
       </p:sp>
       <p:sp>
         <p:nvSpPr>
-          <p:cNvPr id="7" name="Shape 5"/>
+          <p:cNvPr id="11" name="Shape 9"/>
           <p:cNvSpPr/>
           <p:nvPr/>
         </p:nvSpPr>
@@ -4498,7 +4789,7 @@
       </p:sp>
       <p:sp>
         <p:nvSpPr>
-          <p:cNvPr id="8" name="Text 6"/>
+          <p:cNvPr id="12" name="Text 10"/>
           <p:cNvSpPr/>
           <p:nvPr/>
         </p:nvSpPr>
@@ -4537,7 +4828,7 @@
       </p:sp>
       <p:sp>
         <p:nvSpPr>
-          <p:cNvPr id="9" name="Text 7"/>
+          <p:cNvPr id="13" name="Text 11"/>
           <p:cNvSpPr/>
           <p:nvPr/>
         </p:nvSpPr>
@@ -4635,7 +4926,7 @@
                 <a:ea typeface="Calibri" pitchFamily="34" charset="-122"/>
                 <a:cs typeface="Calibri" pitchFamily="34" charset="-120"/>
               </a:rPr>
-              <a:t>1 fait(s) au-dessus du normal dans les 36 dernières heures.</a:t>
+              <a:t>2 fait(s) au-dessus du normal dans les 36 dernières heures.</a:t>
             </a:r>
             <a:endParaRPr lang="en-US" sz="1200" dirty="0"/>
           </a:p>
@@ -4643,7 +4934,7 @@
       </p:sp>
       <p:pic>
         <p:nvPicPr>
-          <p:cNvPr id="10" name="Image 0" descr="/home/runner/work/SentiqS/SentiqS/scripts/assets/grsci/logo-grsci.png">    </p:cNvPr>
+          <p:cNvPr id="14" name="Image 0" descr="/home/runner/work/SentiqS/SentiqS/scripts/assets/grsci/logo-grsci.png">    </p:cNvPr>
           <p:cNvPicPr>
             <a:picLocks noChangeAspect="1"/>
           </p:cNvPicPr>
@@ -4667,7 +4958,7 @@
       </p:pic>
       <p:sp>
         <p:nvSpPr>
-          <p:cNvPr id="11" name="Text 8"/>
+          <p:cNvPr id="15" name="Text 12"/>
           <p:cNvSpPr/>
           <p:nvPr/>
         </p:nvSpPr>
@@ -4836,7 +5127,7 @@
       </p:sp>
       <p:sp>
         <p:nvSpPr>
-          <p:cNvPr id="12" name="Text 9"/>
+          <p:cNvPr id="16" name="Text 13"/>
           <p:cNvSpPr/>
           <p:nvPr/>
         </p:nvSpPr>
@@ -4925,17 +5216,17 @@
               <a:buNone/>
             </a:pPr>
             <a:r>
-              <a:rPr lang="en-US" sz="2200" b="1" dirty="0">
+              <a:rPr lang="en-US" sz="2400" dirty="0">
                 <a:solidFill>
                   <a:srgbClr val="FFFFFF"/>
                 </a:solidFill>
-                <a:latin typeface="Calibri" pitchFamily="34" charset="0"/>
-                <a:ea typeface="Calibri" pitchFamily="34" charset="-122"/>
-                <a:cs typeface="Calibri" pitchFamily="34" charset="-120"/>
+                <a:latin typeface="Arial Narrow" pitchFamily="34" charset="0"/>
+                <a:ea typeface="Arial Narrow" pitchFamily="34" charset="-122"/>
+                <a:cs typeface="Arial Narrow" pitchFamily="34" charset="-120"/>
               </a:rPr>
               <a:t>I</a:t>
             </a:r>
-            <a:endParaRPr lang="en-US" sz="2200" dirty="0"/>
+            <a:endParaRPr lang="en-US" sz="2400" dirty="0"/>
           </a:p>
         </p:txBody>
       </p:sp>
@@ -4964,13 +5255,13 @@
               <a:buNone/>
             </a:pPr>
             <a:r>
-              <a:rPr lang="en-US" sz="2800" b="1" dirty="0">
+              <a:rPr lang="en-US" sz="2800" u="sng" dirty="0">
                 <a:solidFill>
                   <a:srgbClr val="1F6B5E"/>
                 </a:solidFill>
-                <a:latin typeface="Calibri" pitchFamily="34" charset="0"/>
-                <a:ea typeface="Calibri" pitchFamily="34" charset="-122"/>
-                <a:cs typeface="Calibri" pitchFamily="34" charset="-120"/>
+                <a:latin typeface="Arial Narrow" pitchFamily="34" charset="0"/>
+                <a:ea typeface="Arial Narrow" pitchFamily="34" charset="-122"/>
+                <a:cs typeface="Arial Narrow" pitchFamily="34" charset="-120"/>
               </a:rPr>
               <a:t>Togo : situation au 21/10/26</a:t>
             </a:r>
@@ -4981,6 +5272,153 @@
       <p:sp>
         <p:nvSpPr>
           <p:cNvPr id="4" name="Shape 2"/>
+          <p:cNvSpPr/>
+          <p:nvPr/>
+        </p:nvSpPr>
+        <p:spPr>
+          <a:xfrm>
+            <a:off x="10881360" y="274320"/>
+            <a:ext cx="905256" cy="113386"/>
+          </a:xfrm>
+          <a:prstGeom prst="rect">
+            <a:avLst/>
+          </a:prstGeom>
+          <a:solidFill>
+            <a:srgbClr val="006A4E"/>
+          </a:solidFill>
+          <a:ln w="12700">
+            <a:solidFill>
+              <a:srgbClr val="006A4E"/>
+            </a:solidFill>
+            <a:prstDash val="solid"/>
+          </a:ln>
+        </p:spPr>
+      </p:sp>
+      <p:sp>
+        <p:nvSpPr>
+          <p:cNvPr id="5" name="Shape 3"/>
+          <p:cNvSpPr/>
+          <p:nvPr/>
+        </p:nvSpPr>
+        <p:spPr>
+          <a:xfrm>
+            <a:off x="10881360" y="387706"/>
+            <a:ext cx="905256" cy="113386"/>
+          </a:xfrm>
+          <a:prstGeom prst="rect">
+            <a:avLst/>
+          </a:prstGeom>
+          <a:solidFill>
+            <a:srgbClr val="FFCE00"/>
+          </a:solidFill>
+          <a:ln w="12700">
+            <a:solidFill>
+              <a:srgbClr val="FFCE00"/>
+            </a:solidFill>
+            <a:prstDash val="solid"/>
+          </a:ln>
+        </p:spPr>
+      </p:sp>
+      <p:sp>
+        <p:nvSpPr>
+          <p:cNvPr id="6" name="Shape 4"/>
+          <p:cNvSpPr/>
+          <p:nvPr/>
+        </p:nvSpPr>
+        <p:spPr>
+          <a:xfrm>
+            <a:off x="10881360" y="501091"/>
+            <a:ext cx="905256" cy="113386"/>
+          </a:xfrm>
+          <a:prstGeom prst="rect">
+            <a:avLst/>
+          </a:prstGeom>
+          <a:solidFill>
+            <a:srgbClr val="006A4E"/>
+          </a:solidFill>
+          <a:ln w="12700">
+            <a:solidFill>
+              <a:srgbClr val="006A4E"/>
+            </a:solidFill>
+            <a:prstDash val="solid"/>
+          </a:ln>
+        </p:spPr>
+      </p:sp>
+      <p:sp>
+        <p:nvSpPr>
+          <p:cNvPr id="7" name="Shape 5"/>
+          <p:cNvSpPr/>
+          <p:nvPr/>
+        </p:nvSpPr>
+        <p:spPr>
+          <a:xfrm>
+            <a:off x="10881360" y="614477"/>
+            <a:ext cx="905256" cy="113386"/>
+          </a:xfrm>
+          <a:prstGeom prst="rect">
+            <a:avLst/>
+          </a:prstGeom>
+          <a:solidFill>
+            <a:srgbClr val="FFCE00"/>
+          </a:solidFill>
+          <a:ln w="12700">
+            <a:solidFill>
+              <a:srgbClr val="FFCE00"/>
+            </a:solidFill>
+            <a:prstDash val="solid"/>
+          </a:ln>
+        </p:spPr>
+      </p:sp>
+      <p:sp>
+        <p:nvSpPr>
+          <p:cNvPr id="8" name="Shape 6"/>
+          <p:cNvSpPr/>
+          <p:nvPr/>
+        </p:nvSpPr>
+        <p:spPr>
+          <a:xfrm>
+            <a:off x="10881360" y="727862"/>
+            <a:ext cx="905256" cy="113386"/>
+          </a:xfrm>
+          <a:prstGeom prst="rect">
+            <a:avLst/>
+          </a:prstGeom>
+          <a:solidFill>
+            <a:srgbClr val="006A4E"/>
+          </a:solidFill>
+          <a:ln w="12700">
+            <a:solidFill>
+              <a:srgbClr val="006A4E"/>
+            </a:solidFill>
+            <a:prstDash val="solid"/>
+          </a:ln>
+        </p:spPr>
+      </p:sp>
+      <p:sp>
+        <p:nvSpPr>
+          <p:cNvPr id="9" name="Shape 7"/>
+          <p:cNvSpPr/>
+          <p:nvPr/>
+        </p:nvSpPr>
+        <p:spPr>
+          <a:xfrm>
+            <a:off x="10881360" y="274320"/>
+            <a:ext cx="905256" cy="566928"/>
+          </a:xfrm>
+          <a:prstGeom prst="rect">
+            <a:avLst/>
+          </a:prstGeom>
+          <a:ln w="6350">
+            <a:solidFill>
+              <a:srgbClr val="1F2937"/>
+            </a:solidFill>
+            <a:prstDash val="solid"/>
+          </a:ln>
+        </p:spPr>
+      </p:sp>
+      <p:sp>
+        <p:nvSpPr>
+          <p:cNvPr id="10" name="Shape 8"/>
           <p:cNvSpPr/>
           <p:nvPr/>
         </p:nvSpPr>
@@ -5003,7 +5441,7 @@
       </p:sp>
       <p:sp>
         <p:nvSpPr>
-          <p:cNvPr id="5" name="Text 3"/>
+          <p:cNvPr id="11" name="Text 9"/>
           <p:cNvSpPr/>
           <p:nvPr/>
         </p:nvSpPr>
@@ -5044,7 +5482,7 @@
       </p:sp>
       <p:sp>
         <p:nvSpPr>
-          <p:cNvPr id="6" name="Text 4"/>
+          <p:cNvPr id="12" name="Text 10"/>
           <p:cNvSpPr/>
           <p:nvPr/>
         </p:nvSpPr>
@@ -5120,7 +5558,7 @@
                 <a:ea typeface="Calibri" pitchFamily="34" charset="-122"/>
                 <a:cs typeface="Calibri" pitchFamily="34" charset="-120"/>
               </a:rPr>
-              <a:t>Systèmes agroalimentaires : Le Togo engagé à traduire la Déclaration de Kampala en actions concrètes</a:t>
+              <a:t>Togo- Les leaders du CNCC invités à reporter leur meeting</a:t>
             </a:r>
             <a:endParaRPr lang="en-US" sz="1300" dirty="0"/>
           </a:p>
@@ -5140,7 +5578,7 @@
                 <a:ea typeface="Calibri" pitchFamily="34" charset="-122"/>
                 <a:cs typeface="Calibri" pitchFamily="34" charset="-120"/>
               </a:rPr>
-              <a:t>Togo-Presse · 20/10 20h UTC · niveau modéré · Non confirmé</a:t>
+              <a:t>Icilome · 21/10 06h UTC · niveau modéré · Non confirmé</a:t>
             </a:r>
             <a:endParaRPr lang="en-US" sz="1300" dirty="0"/>
           </a:p>
@@ -5161,7 +5599,7 @@
                 <a:ea typeface="Calibri" pitchFamily="34" charset="-122"/>
                 <a:cs typeface="Calibri" pitchFamily="34" charset="-120"/>
               </a:rPr>
-              <a:t>Pintade, sécurité alimentaire et revenus</a:t>
+              <a:t>Systèmes agroalimentaires : Le Togo engagé à traduire la Déclaration de Kampala en actions concrètes</a:t>
             </a:r>
             <a:endParaRPr lang="en-US" sz="1300" dirty="0"/>
           </a:p>
@@ -5181,15 +5619,56 @@
                 <a:ea typeface="Calibri" pitchFamily="34" charset="-122"/>
                 <a:cs typeface="Calibri" pitchFamily="34" charset="-120"/>
               </a:rPr>
-              <a:t>AllAfrica (TG) · 20/10 09h UTC · niveau modéré · Probable</a:t>
+              <a:t>Togo-Presse · 20/10 20h UTC · niveau modéré · Non confirmé</a:t>
             </a:r>
             <a:endParaRPr lang="en-US" sz="1300" dirty="0"/>
           </a:p>
+          <a:p>
+            <a:pPr marL="342900" indent="-342900">
+              <a:spcAft>
+                <a:spcPts val="300"/>
+              </a:spcAft>
+              <a:buSzPct val="100000"/>
+              <a:buChar char="✓"/>
+            </a:pPr>
+            <a:r>
+              <a:rPr lang="en-US" sz="1300" b="1" dirty="0">
+                <a:solidFill>
+                  <a:srgbClr val="1F2937"/>
+                </a:solidFill>
+                <a:latin typeface="Calibri" pitchFamily="34" charset="0"/>
+                <a:ea typeface="Calibri" pitchFamily="34" charset="-122"/>
+                <a:cs typeface="Calibri" pitchFamily="34" charset="-120"/>
+              </a:rPr>
+              <a:t>Lomé : une flèche verte aux feux tricolores pour fluidifier la circulation et sécuriser les carrefours</a:t>
+            </a:r>
+            <a:endParaRPr lang="en-US" sz="1300" dirty="0"/>
+          </a:p>
+          <a:p>
+            <a:pPr lvl="1" indent="0" marL="0">
+              <a:spcAft>
+                <a:spcPts val="300"/>
+              </a:spcAft>
+              <a:buNone/>
+            </a:pPr>
+            <a:r>
+              <a:rPr lang="en-US" sz="1100" i="1" dirty="0">
+                <a:solidFill>
+                  <a:srgbClr val="6B7280"/>
+                </a:solidFill>
+                <a:latin typeface="Calibri" pitchFamily="34" charset="0"/>
+                <a:ea typeface="Calibri" pitchFamily="34" charset="-122"/>
+                <a:cs typeface="Calibri" pitchFamily="34" charset="-120"/>
+              </a:rPr>
+              <a:t>Le Nouveau Reporter · 20/10 16h UTC · niveau modéré · Non confirmé</a:t>
+            </a:r>
+            <a:endParaRPr lang="en-US" sz="1300" dirty="0"/>
+          </a:p>
         </p:txBody>
       </p:sp>
       <p:sp>
         <p:nvSpPr>
-          <p:cNvPr id="7" name="Shape 5"/>
+          <p:cNvPr id="13" name="Shape 11"/>
           <p:cNvSpPr/>
           <p:nvPr/>
         </p:nvSpPr>
@@ -5214,7 +5693,7 @@
       </p:sp>
       <p:sp>
         <p:nvSpPr>
-          <p:cNvPr id="8" name="Text 6"/>
+          <p:cNvPr id="14" name="Text 12"/>
           <p:cNvSpPr/>
           <p:nvPr/>
         </p:nvSpPr>
@@ -5253,7 +5732,7 @@
       </p:sp>
       <p:sp>
         <p:nvSpPr>
-          <p:cNvPr id="9" name="Text 7"/>
+          <p:cNvPr id="15" name="Text 13"/>
           <p:cNvSpPr/>
           <p:nvPr/>
         </p:nvSpPr>
@@ -5351,7 +5830,7 @@
                 <a:ea typeface="Calibri" pitchFamily="34" charset="-122"/>
                 <a:cs typeface="Calibri" pitchFamily="34" charset="-120"/>
               </a:rPr>
-              <a:t>3 fait(s) au-dessus du normal dans les 36 dernières heures.</a:t>
+              <a:t>5 fait(s) au-dessus du normal dans les 36 dernières heures.</a:t>
             </a:r>
             <a:endParaRPr lang="en-US" sz="1200" dirty="0"/>
           </a:p>
@@ -5359,7 +5838,7 @@
       </p:sp>
       <p:pic>
         <p:nvPicPr>
-          <p:cNvPr id="10" name="Image 0" descr="/home/runner/work/SentiqS/SentiqS/scripts/assets/grsci/logo-grsci.png">    </p:cNvPr>
+          <p:cNvPr id="16" name="Image 0" descr="/home/runner/work/SentiqS/SentiqS/scripts/assets/grsci/logo-grsci.png">    </p:cNvPr>
           <p:cNvPicPr>
             <a:picLocks noChangeAspect="1"/>
           </p:cNvPicPr>
@@ -5383,7 +5862,7 @@
       </p:pic>
       <p:sp>
         <p:nvSpPr>
-          <p:cNvPr id="11" name="Text 8"/>
+          <p:cNvPr id="17" name="Text 14"/>
           <p:cNvSpPr/>
           <p:nvPr/>
         </p:nvSpPr>
@@ -5552,7 +6031,7 @@
       </p:sp>
       <p:sp>
         <p:nvSpPr>
-          <p:cNvPr id="12" name="Text 9"/>
+          <p:cNvPr id="18" name="Text 15"/>
           <p:cNvSpPr/>
           <p:nvPr/>
         </p:nvSpPr>
@@ -5641,17 +6120,17 @@
               <a:buNone/>
             </a:pPr>
             <a:r>
-              <a:rPr lang="en-US" sz="2200" b="1" dirty="0">
+              <a:rPr lang="en-US" sz="2400" dirty="0">
                 <a:solidFill>
                   <a:srgbClr val="FFFFFF"/>
                 </a:solidFill>
-                <a:latin typeface="Calibri" pitchFamily="34" charset="0"/>
-                <a:ea typeface="Calibri" pitchFamily="34" charset="-122"/>
-                <a:cs typeface="Calibri" pitchFamily="34" charset="-120"/>
+                <a:latin typeface="Arial Narrow" pitchFamily="34" charset="0"/>
+                <a:ea typeface="Arial Narrow" pitchFamily="34" charset="-122"/>
+                <a:cs typeface="Arial Narrow" pitchFamily="34" charset="-120"/>
               </a:rPr>
               <a:t>I</a:t>
             </a:r>
-            <a:endParaRPr lang="en-US" sz="2200" dirty="0"/>
+            <a:endParaRPr lang="en-US" sz="2400" dirty="0"/>
           </a:p>
         </p:txBody>
       </p:sp>
@@ -5680,13 +6159,13 @@
               <a:buNone/>
             </a:pPr>
             <a:r>
-              <a:rPr lang="en-US" sz="2800" b="1" dirty="0">
+              <a:rPr lang="en-US" sz="2800" u="sng" dirty="0">
                 <a:solidFill>
                   <a:srgbClr val="1F6B5E"/>
                 </a:solidFill>
-                <a:latin typeface="Calibri" pitchFamily="34" charset="0"/>
-                <a:ea typeface="Calibri" pitchFamily="34" charset="-122"/>
-                <a:cs typeface="Calibri" pitchFamily="34" charset="-120"/>
+                <a:latin typeface="Arial Narrow" pitchFamily="34" charset="0"/>
+                <a:ea typeface="Arial Narrow" pitchFamily="34" charset="-122"/>
+                <a:cs typeface="Arial Narrow" pitchFamily="34" charset="-120"/>
               </a:rPr>
               <a:t>Bénin : situation au 21/10/26</a:t>
             </a:r>
@@ -5697,6 +6176,103 @@
       <p:sp>
         <p:nvSpPr>
           <p:cNvPr id="4" name="Shape 2"/>
+          <p:cNvSpPr/>
+          <p:nvPr/>
+        </p:nvSpPr>
+        <p:spPr>
+          <a:xfrm>
+            <a:off x="10881360" y="274320"/>
+            <a:ext cx="362102" cy="566928"/>
+          </a:xfrm>
+          <a:prstGeom prst="rect">
+            <a:avLst/>
+          </a:prstGeom>
+          <a:solidFill>
+            <a:srgbClr val="008751"/>
+          </a:solidFill>
+          <a:ln w="12700">
+            <a:solidFill>
+              <a:srgbClr val="008751"/>
+            </a:solidFill>
+            <a:prstDash val="solid"/>
+          </a:ln>
+        </p:spPr>
+      </p:sp>
+      <p:sp>
+        <p:nvSpPr>
+          <p:cNvPr id="5" name="Shape 3"/>
+          <p:cNvSpPr/>
+          <p:nvPr/>
+        </p:nvSpPr>
+        <p:spPr>
+          <a:xfrm>
+            <a:off x="11243462" y="274320"/>
+            <a:ext cx="543154" cy="283464"/>
+          </a:xfrm>
+          <a:prstGeom prst="rect">
+            <a:avLst/>
+          </a:prstGeom>
+          <a:solidFill>
+            <a:srgbClr val="FCD116"/>
+          </a:solidFill>
+          <a:ln w="12700">
+            <a:solidFill>
+              <a:srgbClr val="FCD116"/>
+            </a:solidFill>
+            <a:prstDash val="solid"/>
+          </a:ln>
+        </p:spPr>
+      </p:sp>
+      <p:sp>
+        <p:nvSpPr>
+          <p:cNvPr id="6" name="Shape 4"/>
+          <p:cNvSpPr/>
+          <p:nvPr/>
+        </p:nvSpPr>
+        <p:spPr>
+          <a:xfrm>
+            <a:off x="11243462" y="557784"/>
+            <a:ext cx="543154" cy="283464"/>
+          </a:xfrm>
+          <a:prstGeom prst="rect">
+            <a:avLst/>
+          </a:prstGeom>
+          <a:solidFill>
+            <a:srgbClr val="E8112D"/>
+          </a:solidFill>
+          <a:ln w="12700">
+            <a:solidFill>
+              <a:srgbClr val="E8112D"/>
+            </a:solidFill>
+            <a:prstDash val="solid"/>
+          </a:ln>
+        </p:spPr>
+      </p:sp>
+      <p:sp>
+        <p:nvSpPr>
+          <p:cNvPr id="7" name="Shape 5"/>
+          <p:cNvSpPr/>
+          <p:nvPr/>
+        </p:nvSpPr>
+        <p:spPr>
+          <a:xfrm>
+            <a:off x="10881360" y="274320"/>
+            <a:ext cx="905256" cy="566928"/>
+          </a:xfrm>
+          <a:prstGeom prst="rect">
+            <a:avLst/>
+          </a:prstGeom>
+          <a:ln w="6350">
+            <a:solidFill>
+              <a:srgbClr val="1F2937"/>
+            </a:solidFill>
+            <a:prstDash val="solid"/>
+          </a:ln>
+        </p:spPr>
+      </p:sp>
+      <p:sp>
+        <p:nvSpPr>
+          <p:cNvPr id="8" name="Shape 6"/>
           <p:cNvSpPr/>
           <p:nvPr/>
         </p:nvSpPr>
@@ -5719,7 +6295,7 @@
       </p:sp>
       <p:sp>
         <p:nvSpPr>
-          <p:cNvPr id="5" name="Text 3"/>
+          <p:cNvPr id="9" name="Text 7"/>
           <p:cNvSpPr/>
           <p:nvPr/>
         </p:nvSpPr>
@@ -5760,7 +6336,7 @@
       </p:sp>
       <p:sp>
         <p:nvSpPr>
-          <p:cNvPr id="6" name="Text 4"/>
+          <p:cNvPr id="10" name="Text 8"/>
           <p:cNvSpPr/>
           <p:nvPr/>
         </p:nvSpPr>
@@ -5823,7 +6399,7 @@
       </p:sp>
       <p:sp>
         <p:nvSpPr>
-          <p:cNvPr id="7" name="Shape 5"/>
+          <p:cNvPr id="11" name="Shape 9"/>
           <p:cNvSpPr/>
           <p:nvPr/>
         </p:nvSpPr>
@@ -5848,7 +6424,7 @@
       </p:sp>
       <p:sp>
         <p:nvSpPr>
-          <p:cNvPr id="8" name="Text 6"/>
+          <p:cNvPr id="12" name="Text 10"/>
           <p:cNvSpPr/>
           <p:nvPr/>
         </p:nvSpPr>
@@ -5887,7 +6463,7 @@
       </p:sp>
       <p:sp>
         <p:nvSpPr>
-          <p:cNvPr id="9" name="Text 7"/>
+          <p:cNvPr id="13" name="Text 11"/>
           <p:cNvSpPr/>
           <p:nvPr/>
         </p:nvSpPr>
@@ -6014,7 +6590,7 @@
       </p:sp>
       <p:pic>
         <p:nvPicPr>
-          <p:cNvPr id="10" name="Image 0" descr="/home/runner/work/SentiqS/SentiqS/scripts/assets/grsci/logo-grsci.png">    </p:cNvPr>
+          <p:cNvPr id="14" name="Image 0" descr="/home/runner/work/SentiqS/SentiqS/scripts/assets/grsci/logo-grsci.png">    </p:cNvPr>
           <p:cNvPicPr>
             <a:picLocks noChangeAspect="1"/>
           </p:cNvPicPr>
@@ -6038,7 +6614,7 @@
       </p:pic>
       <p:sp>
         <p:nvSpPr>
-          <p:cNvPr id="11" name="Text 8"/>
+          <p:cNvPr id="15" name="Text 12"/>
           <p:cNvSpPr/>
           <p:nvPr/>
         </p:nvSpPr>
@@ -6207,7 +6783,7 @@
       </p:sp>
       <p:sp>
         <p:nvSpPr>
-          <p:cNvPr id="12" name="Text 9"/>
+          <p:cNvPr id="16" name="Text 13"/>
           <p:cNvSpPr/>
           <p:nvPr/>
         </p:nvSpPr>
@@ -6296,17 +6872,17 @@
               <a:buNone/>
             </a:pPr>
             <a:r>
-              <a:rPr lang="en-US" sz="2200" b="1" dirty="0">
+              <a:rPr lang="en-US" sz="2400" dirty="0">
                 <a:solidFill>
                   <a:srgbClr val="FFFFFF"/>
                 </a:solidFill>
-                <a:latin typeface="Calibri" pitchFamily="34" charset="0"/>
-                <a:ea typeface="Calibri" pitchFamily="34" charset="-122"/>
-                <a:cs typeface="Calibri" pitchFamily="34" charset="-120"/>
+                <a:latin typeface="Arial Narrow" pitchFamily="34" charset="0"/>
+                <a:ea typeface="Arial Narrow" pitchFamily="34" charset="-122"/>
+                <a:cs typeface="Arial Narrow" pitchFamily="34" charset="-120"/>
               </a:rPr>
               <a:t>I</a:t>
             </a:r>
-            <a:endParaRPr lang="en-US" sz="2200" dirty="0"/>
+            <a:endParaRPr lang="en-US" sz="2400" dirty="0"/>
           </a:p>
         </p:txBody>
       </p:sp>
@@ -6335,13 +6911,13 @@
               <a:buNone/>
             </a:pPr>
             <a:r>
-              <a:rPr lang="en-US" sz="2800" b="1" dirty="0">
+              <a:rPr lang="en-US" sz="2800" u="sng" dirty="0">
                 <a:solidFill>
                   <a:srgbClr val="1F6B5E"/>
                 </a:solidFill>
-                <a:latin typeface="Calibri" pitchFamily="34" charset="0"/>
-                <a:ea typeface="Calibri" pitchFamily="34" charset="-122"/>
-                <a:cs typeface="Calibri" pitchFamily="34" charset="-120"/>
+                <a:latin typeface="Arial Narrow" pitchFamily="34" charset="0"/>
+                <a:ea typeface="Arial Narrow" pitchFamily="34" charset="-122"/>
+                <a:cs typeface="Arial Narrow" pitchFamily="34" charset="-120"/>
               </a:rPr>
               <a:t>Guinée : situation au 21/10/26</a:t>
             </a:r>
@@ -6352,6 +6928,103 @@
       <p:sp>
         <p:nvSpPr>
           <p:cNvPr id="4" name="Shape 2"/>
+          <p:cNvSpPr/>
+          <p:nvPr/>
+        </p:nvSpPr>
+        <p:spPr>
+          <a:xfrm>
+            <a:off x="10881360" y="274320"/>
+            <a:ext cx="301752" cy="566928"/>
+          </a:xfrm>
+          <a:prstGeom prst="rect">
+            <a:avLst/>
+          </a:prstGeom>
+          <a:solidFill>
+            <a:srgbClr val="CE1126"/>
+          </a:solidFill>
+          <a:ln w="12700">
+            <a:solidFill>
+              <a:srgbClr val="CE1126"/>
+            </a:solidFill>
+            <a:prstDash val="solid"/>
+          </a:ln>
+        </p:spPr>
+      </p:sp>
+      <p:sp>
+        <p:nvSpPr>
+          <p:cNvPr id="5" name="Shape 3"/>
+          <p:cNvSpPr/>
+          <p:nvPr/>
+        </p:nvSpPr>
+        <p:spPr>
+          <a:xfrm>
+            <a:off x="11183112" y="274320"/>
+            <a:ext cx="301752" cy="566928"/>
+          </a:xfrm>
+          <a:prstGeom prst="rect">
+            <a:avLst/>
+          </a:prstGeom>
+          <a:solidFill>
+            <a:srgbClr val="FCD116"/>
+          </a:solidFill>
+          <a:ln w="12700">
+            <a:solidFill>
+              <a:srgbClr val="FCD116"/>
+            </a:solidFill>
+            <a:prstDash val="solid"/>
+          </a:ln>
+        </p:spPr>
+      </p:sp>
+      <p:sp>
+        <p:nvSpPr>
+          <p:cNvPr id="6" name="Shape 4"/>
+          <p:cNvSpPr/>
+          <p:nvPr/>
+        </p:nvSpPr>
+        <p:spPr>
+          <a:xfrm>
+            <a:off x="11484864" y="274320"/>
+            <a:ext cx="301752" cy="566928"/>
+          </a:xfrm>
+          <a:prstGeom prst="rect">
+            <a:avLst/>
+          </a:prstGeom>
+          <a:solidFill>
+            <a:srgbClr val="009460"/>
+          </a:solidFill>
+          <a:ln w="12700">
+            <a:solidFill>
+              <a:srgbClr val="009460"/>
+            </a:solidFill>
+            <a:prstDash val="solid"/>
+          </a:ln>
+        </p:spPr>
+      </p:sp>
+      <p:sp>
+        <p:nvSpPr>
+          <p:cNvPr id="7" name="Shape 5"/>
+          <p:cNvSpPr/>
+          <p:nvPr/>
+        </p:nvSpPr>
+        <p:spPr>
+          <a:xfrm>
+            <a:off x="10881360" y="274320"/>
+            <a:ext cx="905256" cy="566928"/>
+          </a:xfrm>
+          <a:prstGeom prst="rect">
+            <a:avLst/>
+          </a:prstGeom>
+          <a:ln w="6350">
+            <a:solidFill>
+              <a:srgbClr val="1F2937"/>
+            </a:solidFill>
+            <a:prstDash val="solid"/>
+          </a:ln>
+        </p:spPr>
+      </p:sp>
+      <p:sp>
+        <p:nvSpPr>
+          <p:cNvPr id="8" name="Shape 6"/>
           <p:cNvSpPr/>
           <p:nvPr/>
         </p:nvSpPr>
@@ -6374,7 +7047,7 @@
       </p:sp>
       <p:sp>
         <p:nvSpPr>
-          <p:cNvPr id="5" name="Text 3"/>
+          <p:cNvPr id="9" name="Text 7"/>
           <p:cNvSpPr/>
           <p:nvPr/>
         </p:nvSpPr>
@@ -6415,7 +7088,7 @@
       </p:sp>
       <p:sp>
         <p:nvSpPr>
-          <p:cNvPr id="6" name="Text 4"/>
+          <p:cNvPr id="10" name="Text 8"/>
           <p:cNvSpPr/>
           <p:nvPr/>
         </p:nvSpPr>
@@ -6491,7 +7164,7 @@
                 <a:ea typeface="Calibri" pitchFamily="34" charset="-122"/>
                 <a:cs typeface="Calibri" pitchFamily="34" charset="-120"/>
               </a:rPr>
-              <a:t>Web TV illégales en Guinée : la HAC sort la menace des sanctions</a:t>
+              <a:t>Kindia : un accident de bus fait deux morts et 34 blessés à Séguéya</a:t>
             </a:r>
             <a:endParaRPr lang="en-US" sz="1300" dirty="0"/>
           </a:p>
@@ -6511,7 +7184,7 @@
                 <a:ea typeface="Calibri" pitchFamily="34" charset="-122"/>
                 <a:cs typeface="Calibri" pitchFamily="34" charset="-120"/>
               </a:rPr>
-              <a:t>Guinee7.com · 20/10 11h UTC · niveau élevé · Non confirmé</a:t>
+              <a:t>Guineelive · 19/10 23h UTC · niveau élevé · Non confirmé</a:t>
             </a:r>
             <a:endParaRPr lang="en-US" sz="1300" dirty="0"/>
           </a:p>
@@ -6532,7 +7205,7 @@
                 <a:ea typeface="Calibri" pitchFamily="34" charset="-122"/>
                 <a:cs typeface="Calibri" pitchFamily="34" charset="-120"/>
               </a:rPr>
-              <a:t>Kindia : un accident de bus fait deux morts et 34 blessés à Séguéya</a:t>
+              <a:t>Lélouma : des écoles fermées par manque d’enseignants, plus de 500 élèves privés de scolarité</a:t>
             </a:r>
             <a:endParaRPr lang="en-US" sz="1300" dirty="0"/>
           </a:p>
@@ -6552,7 +7225,7 @@
                 <a:ea typeface="Calibri" pitchFamily="34" charset="-122"/>
                 <a:cs typeface="Calibri" pitchFamily="34" charset="-120"/>
               </a:rPr>
-              <a:t>Guineelive · 19/10 23h UTC · niveau élevé · Non confirmé</a:t>
+              <a:t>Guineematin.com · 20/10 22h UTC · niveau modéré · Non confirmé</a:t>
             </a:r>
             <a:endParaRPr lang="en-US" sz="1300" dirty="0"/>
           </a:p>
@@ -6573,7 +7246,7 @@
                 <a:ea typeface="Calibri" pitchFamily="34" charset="-122"/>
                 <a:cs typeface="Calibri" pitchFamily="34" charset="-120"/>
               </a:rPr>
-              <a:t>Lélouma : des écoles fermées par manque d’enseignants, plus de 500 élèves privés de scolarité</a:t>
+              <a:t>OGP : « Écouter sans perdre de temps », Mohamed Bang’s Bangoura fixe le cap</a:t>
             </a:r>
             <a:endParaRPr lang="en-US" sz="1300" dirty="0"/>
           </a:p>
@@ -6593,7 +7266,7 @@
                 <a:ea typeface="Calibri" pitchFamily="34" charset="-122"/>
                 <a:cs typeface="Calibri" pitchFamily="34" charset="-120"/>
               </a:rPr>
-              <a:t>Guineematin.com · 20/10 22h UTC · niveau modéré · Non confirmé</a:t>
+              <a:t>Guinee7.com · 20/10 14h UTC · niveau modéré · Non confirmé</a:t>
             </a:r>
             <a:endParaRPr lang="en-US" sz="1300" dirty="0"/>
           </a:p>
@@ -6601,7 +7274,7 @@
       </p:sp>
       <p:sp>
         <p:nvSpPr>
-          <p:cNvPr id="7" name="Shape 5"/>
+          <p:cNvPr id="11" name="Shape 9"/>
           <p:cNvSpPr/>
           <p:nvPr/>
         </p:nvSpPr>
@@ -6626,7 +7299,7 @@
       </p:sp>
       <p:sp>
         <p:nvSpPr>
-          <p:cNvPr id="8" name="Text 6"/>
+          <p:cNvPr id="12" name="Text 10"/>
           <p:cNvSpPr/>
           <p:nvPr/>
         </p:nvSpPr>
@@ -6665,7 +7338,7 @@
       </p:sp>
       <p:sp>
         <p:nvSpPr>
-          <p:cNvPr id="9" name="Text 7"/>
+          <p:cNvPr id="13" name="Text 11"/>
           <p:cNvSpPr/>
           <p:nvPr/>
         </p:nvSpPr>
@@ -6763,7 +7436,7 @@
                 <a:ea typeface="Calibri" pitchFamily="34" charset="-122"/>
                 <a:cs typeface="Calibri" pitchFamily="34" charset="-120"/>
               </a:rPr>
-              <a:t>5 fait(s) au-dessus du normal dans les 36 dernières heures.</a:t>
+              <a:t>4 fait(s) au-dessus du normal dans les 36 dernières heures.</a:t>
             </a:r>
             <a:endParaRPr lang="en-US" sz="1200" dirty="0"/>
           </a:p>
@@ -6771,7 +7444,7 @@
       </p:sp>
       <p:pic>
         <p:nvPicPr>
-          <p:cNvPr id="10" name="Image 0" descr="/home/runner/work/SentiqS/SentiqS/scripts/assets/grsci/logo-grsci.png">    </p:cNvPr>
+          <p:cNvPr id="14" name="Image 0" descr="/home/runner/work/SentiqS/SentiqS/scripts/assets/grsci/logo-grsci.png">    </p:cNvPr>
           <p:cNvPicPr>
             <a:picLocks noChangeAspect="1"/>
           </p:cNvPicPr>
@@ -6795,7 +7468,7 @@
       </p:pic>
       <p:sp>
         <p:nvSpPr>
-          <p:cNvPr id="11" name="Text 8"/>
+          <p:cNvPr id="15" name="Text 12"/>
           <p:cNvSpPr/>
           <p:nvPr/>
         </p:nvSpPr>
@@ -6964,7 +7637,7 @@
       </p:sp>
       <p:sp>
         <p:nvSpPr>
-          <p:cNvPr id="12" name="Text 9"/>
+          <p:cNvPr id="16" name="Text 13"/>
           <p:cNvSpPr/>
           <p:nvPr/>
         </p:nvSpPr>
@@ -7053,17 +7726,17 @@
               <a:buNone/>
             </a:pPr>
             <a:r>
-              <a:rPr lang="en-US" sz="2200" b="1" dirty="0">
+              <a:rPr lang="en-US" sz="2400" dirty="0">
                 <a:solidFill>
                   <a:srgbClr val="FFFFFF"/>
                 </a:solidFill>
-                <a:latin typeface="Calibri" pitchFamily="34" charset="0"/>
-                <a:ea typeface="Calibri" pitchFamily="34" charset="-122"/>
-                <a:cs typeface="Calibri" pitchFamily="34" charset="-120"/>
+                <a:latin typeface="Arial Narrow" pitchFamily="34" charset="0"/>
+                <a:ea typeface="Arial Narrow" pitchFamily="34" charset="-122"/>
+                <a:cs typeface="Arial Narrow" pitchFamily="34" charset="-120"/>
               </a:rPr>
               <a:t>I</a:t>
             </a:r>
-            <a:endParaRPr lang="en-US" sz="2200" dirty="0"/>
+            <a:endParaRPr lang="en-US" sz="2400" dirty="0"/>
           </a:p>
         </p:txBody>
       </p:sp>
@@ -7092,13 +7765,13 @@
               <a:buNone/>
             </a:pPr>
             <a:r>
-              <a:rPr lang="en-US" sz="2800" b="1" dirty="0">
+              <a:rPr lang="en-US" sz="2800" u="sng" dirty="0">
                 <a:solidFill>
                   <a:srgbClr val="1F6B5E"/>
                 </a:solidFill>
-                <a:latin typeface="Calibri" pitchFamily="34" charset="0"/>
-                <a:ea typeface="Calibri" pitchFamily="34" charset="-122"/>
-                <a:cs typeface="Calibri" pitchFamily="34" charset="-120"/>
+                <a:latin typeface="Arial Narrow" pitchFamily="34" charset="0"/>
+                <a:ea typeface="Arial Narrow" pitchFamily="34" charset="-122"/>
+                <a:cs typeface="Arial Narrow" pitchFamily="34" charset="-120"/>
               </a:rPr>
               <a:t>Liberia : situation au 21/10/26</a:t>
             </a:r>
@@ -7109,6 +7782,153 @@
       <p:sp>
         <p:nvSpPr>
           <p:cNvPr id="4" name="Shape 2"/>
+          <p:cNvSpPr/>
+          <p:nvPr/>
+        </p:nvSpPr>
+        <p:spPr>
+          <a:xfrm>
+            <a:off x="10881360" y="274320"/>
+            <a:ext cx="905256" cy="113386"/>
+          </a:xfrm>
+          <a:prstGeom prst="rect">
+            <a:avLst/>
+          </a:prstGeom>
+          <a:solidFill>
+            <a:srgbClr val="BF0A30"/>
+          </a:solidFill>
+          <a:ln w="12700">
+            <a:solidFill>
+              <a:srgbClr val="BF0A30"/>
+            </a:solidFill>
+            <a:prstDash val="solid"/>
+          </a:ln>
+        </p:spPr>
+      </p:sp>
+      <p:sp>
+        <p:nvSpPr>
+          <p:cNvPr id="5" name="Shape 3"/>
+          <p:cNvSpPr/>
+          <p:nvPr/>
+        </p:nvSpPr>
+        <p:spPr>
+          <a:xfrm>
+            <a:off x="10881360" y="387706"/>
+            <a:ext cx="905256" cy="113386"/>
+          </a:xfrm>
+          <a:prstGeom prst="rect">
+            <a:avLst/>
+          </a:prstGeom>
+          <a:solidFill>
+            <a:srgbClr val="FFFFFF"/>
+          </a:solidFill>
+          <a:ln w="12700">
+            <a:solidFill>
+              <a:srgbClr val="FFFFFF"/>
+            </a:solidFill>
+            <a:prstDash val="solid"/>
+          </a:ln>
+        </p:spPr>
+      </p:sp>
+      <p:sp>
+        <p:nvSpPr>
+          <p:cNvPr id="6" name="Shape 4"/>
+          <p:cNvSpPr/>
+          <p:nvPr/>
+        </p:nvSpPr>
+        <p:spPr>
+          <a:xfrm>
+            <a:off x="10881360" y="501091"/>
+            <a:ext cx="905256" cy="113386"/>
+          </a:xfrm>
+          <a:prstGeom prst="rect">
+            <a:avLst/>
+          </a:prstGeom>
+          <a:solidFill>
+            <a:srgbClr val="BF0A30"/>
+          </a:solidFill>
+          <a:ln w="12700">
+            <a:solidFill>
+              <a:srgbClr val="BF0A30"/>
+            </a:solidFill>
+            <a:prstDash val="solid"/>
+          </a:ln>
+        </p:spPr>
+      </p:sp>
+      <p:sp>
+        <p:nvSpPr>
+          <p:cNvPr id="7" name="Shape 5"/>
+          <p:cNvSpPr/>
+          <p:nvPr/>
+        </p:nvSpPr>
+        <p:spPr>
+          <a:xfrm>
+            <a:off x="10881360" y="614477"/>
+            <a:ext cx="905256" cy="113386"/>
+          </a:xfrm>
+          <a:prstGeom prst="rect">
+            <a:avLst/>
+          </a:prstGeom>
+          <a:solidFill>
+            <a:srgbClr val="FFFFFF"/>
+          </a:solidFill>
+          <a:ln w="12700">
+            <a:solidFill>
+              <a:srgbClr val="FFFFFF"/>
+            </a:solidFill>
+            <a:prstDash val="solid"/>
+          </a:ln>
+        </p:spPr>
+      </p:sp>
+      <p:sp>
+        <p:nvSpPr>
+          <p:cNvPr id="8" name="Shape 6"/>
+          <p:cNvSpPr/>
+          <p:nvPr/>
+        </p:nvSpPr>
+        <p:spPr>
+          <a:xfrm>
+            <a:off x="10881360" y="727862"/>
+            <a:ext cx="905256" cy="113386"/>
+          </a:xfrm>
+          <a:prstGeom prst="rect">
+            <a:avLst/>
+          </a:prstGeom>
+          <a:solidFill>
+            <a:srgbClr val="BF0A30"/>
+          </a:solidFill>
+          <a:ln w="12700">
+            <a:solidFill>
+              <a:srgbClr val="BF0A30"/>
+            </a:solidFill>
+            <a:prstDash val="solid"/>
+          </a:ln>
+        </p:spPr>
+      </p:sp>
+      <p:sp>
+        <p:nvSpPr>
+          <p:cNvPr id="9" name="Shape 7"/>
+          <p:cNvSpPr/>
+          <p:nvPr/>
+        </p:nvSpPr>
+        <p:spPr>
+          <a:xfrm>
+            <a:off x="10881360" y="274320"/>
+            <a:ext cx="905256" cy="566928"/>
+          </a:xfrm>
+          <a:prstGeom prst="rect">
+            <a:avLst/>
+          </a:prstGeom>
+          <a:ln w="6350">
+            <a:solidFill>
+              <a:srgbClr val="1F2937"/>
+            </a:solidFill>
+            <a:prstDash val="solid"/>
+          </a:ln>
+        </p:spPr>
+      </p:sp>
+      <p:sp>
+        <p:nvSpPr>
+          <p:cNvPr id="10" name="Shape 8"/>
           <p:cNvSpPr/>
           <p:nvPr/>
         </p:nvSpPr>
@@ -7131,7 +7951,7 @@
       </p:sp>
       <p:sp>
         <p:nvSpPr>
-          <p:cNvPr id="5" name="Text 3"/>
+          <p:cNvPr id="11" name="Text 9"/>
           <p:cNvSpPr/>
           <p:nvPr/>
         </p:nvSpPr>
@@ -7172,7 +7992,7 @@
       </p:sp>
       <p:sp>
         <p:nvSpPr>
-          <p:cNvPr id="6" name="Text 4"/>
+          <p:cNvPr id="12" name="Text 10"/>
           <p:cNvSpPr/>
           <p:nvPr/>
         </p:nvSpPr>
@@ -7191,51 +8011,30 @@
           <a:bodyPr wrap="square" rtlCol="0" anchor="t"/>
           <a:lstStyle/>
           <a:p>
-            <a:pPr marL="342900" indent="-342900">
+            <a:pPr indent="0" marL="0">
               <a:spcAft>
                 <a:spcPts val="300"/>
               </a:spcAft>
-              <a:buSzPct val="100000"/>
-              <a:buChar char="✓"/>
-            </a:pPr>
-            <a:r>
-              <a:rPr lang="en-US" sz="1300" b="1" dirty="0">
-                <a:solidFill>
-                  <a:srgbClr val="1F2937"/>
-                </a:solidFill>
-                <a:latin typeface="Calibri" pitchFamily="34" charset="0"/>
-                <a:ea typeface="Calibri" pitchFamily="34" charset="-122"/>
-                <a:cs typeface="Calibri" pitchFamily="34" charset="-120"/>
-              </a:rPr>
-              <a:t>Boakai Administration Receives New U.S. Chargé d’Affaires as Diplomatic Focus Turns to Investment, Health, and Security</a:t>
+              <a:buNone/>
+            </a:pPr>
+            <a:r>
+              <a:rPr lang="en-US" sz="1300" dirty="0">
+                <a:solidFill>
+                  <a:srgbClr val="6B7280"/>
+                </a:solidFill>
+                <a:latin typeface="Calibri" pitchFamily="34" charset="0"/>
+                <a:ea typeface="Calibri" pitchFamily="34" charset="-122"/>
+                <a:cs typeface="Calibri" pitchFamily="34" charset="-120"/>
+              </a:rPr>
+              <a:t>Aucun fait au-dessus du normal dans la fenêtre.</a:t>
             </a:r>
             <a:endParaRPr lang="en-US" sz="1300" dirty="0"/>
           </a:p>
-          <a:p>
-            <a:pPr lvl="1" indent="0" marL="0">
-              <a:spcAft>
-                <a:spcPts val="300"/>
-              </a:spcAft>
-              <a:buNone/>
-            </a:pPr>
-            <a:r>
-              <a:rPr lang="en-US" sz="1100" i="1" dirty="0">
-                <a:solidFill>
-                  <a:srgbClr val="6B7280"/>
-                </a:solidFill>
-                <a:latin typeface="Calibri" pitchFamily="34" charset="0"/>
-                <a:ea typeface="Calibri" pitchFamily="34" charset="-122"/>
-                <a:cs typeface="Calibri" pitchFamily="34" charset="-120"/>
-              </a:rPr>
-              <a:t>Global News Network Liberia · 19/10 20h UTC · niveau modéré · Non confirmé</a:t>
-            </a:r>
-            <a:endParaRPr lang="en-US" sz="1300" dirty="0"/>
-          </a:p>
         </p:txBody>
       </p:sp>
       <p:sp>
         <p:nvSpPr>
-          <p:cNvPr id="7" name="Shape 5"/>
+          <p:cNvPr id="13" name="Shape 11"/>
           <p:cNvSpPr/>
           <p:nvPr/>
         </p:nvSpPr>
@@ -7260,7 +8059,7 @@
       </p:sp>
       <p:sp>
         <p:nvSpPr>
-          <p:cNvPr id="8" name="Text 6"/>
+          <p:cNvPr id="14" name="Text 12"/>
           <p:cNvSpPr/>
           <p:nvPr/>
         </p:nvSpPr>
@@ -7299,7 +8098,7 @@
       </p:sp>
       <p:sp>
         <p:nvSpPr>
-          <p:cNvPr id="9" name="Text 7"/>
+          <p:cNvPr id="15" name="Text 13"/>
           <p:cNvSpPr/>
           <p:nvPr/>
         </p:nvSpPr>
@@ -7397,7 +8196,7 @@
                 <a:ea typeface="Calibri" pitchFamily="34" charset="-122"/>
                 <a:cs typeface="Calibri" pitchFamily="34" charset="-120"/>
               </a:rPr>
-              <a:t>1 fait(s) au-dessus du normal dans les 36 dernières heures.</a:t>
+              <a:t>Aucun fait au-dessus du niveau normal dans la fenêtre : cela ne veut pas dire qu'il ne s'est rien passé.</a:t>
             </a:r>
             <a:endParaRPr lang="en-US" sz="1200" dirty="0"/>
           </a:p>
@@ -7405,7 +8204,7 @@
       </p:sp>
       <p:pic>
         <p:nvPicPr>
-          <p:cNvPr id="10" name="Image 0" descr="/home/runner/work/SentiqS/SentiqS/scripts/assets/grsci/logo-grsci.png">    </p:cNvPr>
+          <p:cNvPr id="16" name="Image 0" descr="/home/runner/work/SentiqS/SentiqS/scripts/assets/grsci/logo-grsci.png">    </p:cNvPr>
           <p:cNvPicPr>
             <a:picLocks noChangeAspect="1"/>
           </p:cNvPicPr>
@@ -7429,7 +8228,7 @@
       </p:pic>
       <p:sp>
         <p:nvSpPr>
-          <p:cNvPr id="11" name="Text 8"/>
+          <p:cNvPr id="17" name="Text 14"/>
           <p:cNvSpPr/>
           <p:nvPr/>
         </p:nvSpPr>
@@ -7598,7 +8397,7 @@
       </p:sp>
       <p:sp>
         <p:nvSpPr>
-          <p:cNvPr id="12" name="Text 9"/>
+          <p:cNvPr id="18" name="Text 15"/>
           <p:cNvSpPr/>
           <p:nvPr/>
         </p:nvSpPr>
@@ -7687,17 +8486,17 @@
               <a:buNone/>
             </a:pPr>
             <a:r>
-              <a:rPr lang="en-US" sz="2200" b="1" dirty="0">
+              <a:rPr lang="en-US" sz="2400" dirty="0">
                 <a:solidFill>
                   <a:srgbClr val="FFFFFF"/>
                 </a:solidFill>
-                <a:latin typeface="Calibri" pitchFamily="34" charset="0"/>
-                <a:ea typeface="Calibri" pitchFamily="34" charset="-122"/>
-                <a:cs typeface="Calibri" pitchFamily="34" charset="-120"/>
+                <a:latin typeface="Arial Narrow" pitchFamily="34" charset="0"/>
+                <a:ea typeface="Arial Narrow" pitchFamily="34" charset="-122"/>
+                <a:cs typeface="Arial Narrow" pitchFamily="34" charset="-120"/>
               </a:rPr>
               <a:t>I</a:t>
             </a:r>
-            <a:endParaRPr lang="en-US" sz="2200" dirty="0"/>
+            <a:endParaRPr lang="en-US" sz="2400" dirty="0"/>
           </a:p>
         </p:txBody>
       </p:sp>
@@ -7726,13 +8525,13 @@
               <a:buNone/>
             </a:pPr>
             <a:r>
-              <a:rPr lang="en-US" sz="2800" b="1" dirty="0">
+              <a:rPr lang="en-US" sz="2800" u="sng" dirty="0">
                 <a:solidFill>
                   <a:srgbClr val="1F6B5E"/>
                 </a:solidFill>
-                <a:latin typeface="Calibri" pitchFamily="34" charset="0"/>
-                <a:ea typeface="Calibri" pitchFamily="34" charset="-122"/>
-                <a:cs typeface="Calibri" pitchFamily="34" charset="-120"/>
+                <a:latin typeface="Arial Narrow" pitchFamily="34" charset="0"/>
+                <a:ea typeface="Arial Narrow" pitchFamily="34" charset="-122"/>
+                <a:cs typeface="Arial Narrow" pitchFamily="34" charset="-120"/>
               </a:rPr>
               <a:t>Sénégal : situation au 21/10/26</a:t>
             </a:r>
@@ -7743,6 +8542,103 @@
       <p:sp>
         <p:nvSpPr>
           <p:cNvPr id="4" name="Shape 2"/>
+          <p:cNvSpPr/>
+          <p:nvPr/>
+        </p:nvSpPr>
+        <p:spPr>
+          <a:xfrm>
+            <a:off x="10881360" y="274320"/>
+            <a:ext cx="301752" cy="566928"/>
+          </a:xfrm>
+          <a:prstGeom prst="rect">
+            <a:avLst/>
+          </a:prstGeom>
+          <a:solidFill>
+            <a:srgbClr val="00853F"/>
+          </a:solidFill>
+          <a:ln w="12700">
+            <a:solidFill>
+              <a:srgbClr val="00853F"/>
+            </a:solidFill>
+            <a:prstDash val="solid"/>
+          </a:ln>
+        </p:spPr>
+      </p:sp>
+      <p:sp>
+        <p:nvSpPr>
+          <p:cNvPr id="5" name="Shape 3"/>
+          <p:cNvSpPr/>
+          <p:nvPr/>
+        </p:nvSpPr>
+        <p:spPr>
+          <a:xfrm>
+            <a:off x="11183112" y="274320"/>
+            <a:ext cx="301752" cy="566928"/>
+          </a:xfrm>
+          <a:prstGeom prst="rect">
+            <a:avLst/>
+          </a:prstGeom>
+          <a:solidFill>
+            <a:srgbClr val="FDEF42"/>
+          </a:solidFill>
+          <a:ln w="12700">
+            <a:solidFill>
+              <a:srgbClr val="FDEF42"/>
+            </a:solidFill>
+            <a:prstDash val="solid"/>
+          </a:ln>
+        </p:spPr>
+      </p:sp>
+      <p:sp>
+        <p:nvSpPr>
+          <p:cNvPr id="6" name="Shape 4"/>
+          <p:cNvSpPr/>
+          <p:nvPr/>
+        </p:nvSpPr>
+        <p:spPr>
+          <a:xfrm>
+            <a:off x="11484864" y="274320"/>
+            <a:ext cx="301752" cy="566928"/>
+          </a:xfrm>
+          <a:prstGeom prst="rect">
+            <a:avLst/>
+          </a:prstGeom>
+          <a:solidFill>
+            <a:srgbClr val="E31B23"/>
+          </a:solidFill>
+          <a:ln w="12700">
+            <a:solidFill>
+              <a:srgbClr val="E31B23"/>
+            </a:solidFill>
+            <a:prstDash val="solid"/>
+          </a:ln>
+        </p:spPr>
+      </p:sp>
+      <p:sp>
+        <p:nvSpPr>
+          <p:cNvPr id="7" name="Shape 5"/>
+          <p:cNvSpPr/>
+          <p:nvPr/>
+        </p:nvSpPr>
+        <p:spPr>
+          <a:xfrm>
+            <a:off x="10881360" y="274320"/>
+            <a:ext cx="905256" cy="566928"/>
+          </a:xfrm>
+          <a:prstGeom prst="rect">
+            <a:avLst/>
+          </a:prstGeom>
+          <a:ln w="6350">
+            <a:solidFill>
+              <a:srgbClr val="1F2937"/>
+            </a:solidFill>
+            <a:prstDash val="solid"/>
+          </a:ln>
+        </p:spPr>
+      </p:sp>
+      <p:sp>
+        <p:nvSpPr>
+          <p:cNvPr id="8" name="Shape 6"/>
           <p:cNvSpPr/>
           <p:nvPr/>
         </p:nvSpPr>
@@ -7765,7 +8661,7 @@
       </p:sp>
       <p:sp>
         <p:nvSpPr>
-          <p:cNvPr id="5" name="Text 3"/>
+          <p:cNvPr id="9" name="Text 7"/>
           <p:cNvSpPr/>
           <p:nvPr/>
         </p:nvSpPr>
@@ -7778,7 +8674,7 @@
             <a:avLst/>
           </a:prstGeom>
           <a:solidFill>
-            <a:srgbClr val="CA8A04"/>
+            <a:srgbClr val="EA580C"/>
           </a:solidFill>
           <a:ln/>
         </p:spPr>
@@ -7792,13 +8688,13 @@
             <a:r>
               <a:rPr lang="en-US" sz="1600" b="1" dirty="0">
                 <a:solidFill>
-                  <a:srgbClr val="1F2937"/>
-                </a:solidFill>
-                <a:latin typeface="Calibri" pitchFamily="34" charset="0"/>
-                <a:ea typeface="Calibri" pitchFamily="34" charset="-122"/>
-                <a:cs typeface="Calibri" pitchFamily="34" charset="-120"/>
-              </a:rPr>
-              <a:t>JAUNE</a:t>
+                  <a:srgbClr val="FFFFFF"/>
+                </a:solidFill>
+                <a:latin typeface="Calibri" pitchFamily="34" charset="0"/>
+                <a:ea typeface="Calibri" pitchFamily="34" charset="-122"/>
+                <a:cs typeface="Calibri" pitchFamily="34" charset="-120"/>
+              </a:rPr>
+              <a:t>ORANGE</a:t>
             </a:r>
             <a:endParaRPr lang="en-US" sz="1600" dirty="0"/>
           </a:p>
@@ -7806,7 +8702,7 @@
       </p:sp>
       <p:sp>
         <p:nvSpPr>
-          <p:cNvPr id="6" name="Text 4"/>
+          <p:cNvPr id="10" name="Text 8"/>
           <p:cNvSpPr/>
           <p:nvPr/>
         </p:nvSpPr>
@@ -7841,7 +8737,7 @@
                 <a:ea typeface="Calibri" pitchFamily="34" charset="-122"/>
                 <a:cs typeface="Calibri" pitchFamily="34" charset="-120"/>
               </a:rPr>
-              <a:t>Salaires : Ce que risquent les travailleurs qui seront en grève à partir de ce mercredi</a:t>
+              <a:t>Grève générale : l’État brandit les sanctions, un inspecteur du travail précise les règles…le bras de fer social prend une tournure juridique</a:t>
             </a:r>
             <a:endParaRPr lang="en-US" sz="1300" dirty="0"/>
           </a:p>
@@ -7861,7 +8757,7 @@
                 <a:ea typeface="Calibri" pitchFamily="34" charset="-122"/>
                 <a:cs typeface="Calibri" pitchFamily="34" charset="-120"/>
               </a:rPr>
-              <a:t>SeneNews · 20/10 22h UTC · niveau élevé · Non confirmé</a:t>
+              <a:t>Dakar Actu · 21/10 08h UTC · niveau élevé · Probable</a:t>
             </a:r>
             <a:endParaRPr lang="en-US" sz="1300" dirty="0"/>
           </a:p>
@@ -7882,7 +8778,7 @@
                 <a:ea typeface="Calibri" pitchFamily="34" charset="-122"/>
                 <a:cs typeface="Calibri" pitchFamily="34" charset="-120"/>
               </a:rPr>
-              <a:t>Crise institutionnelle : Amadou Ba parle à Bassirou Diomaye Faye et à Ousmane Sonko</a:t>
+              <a:t>Sénégal : un appel à la grève des travailleurs qui inquiète le pouvoir</a:t>
             </a:r>
             <a:endParaRPr lang="en-US" sz="1300" dirty="0"/>
           </a:p>
@@ -7902,7 +8798,7 @@
                 <a:ea typeface="Calibri" pitchFamily="34" charset="-122"/>
                 <a:cs typeface="Calibri" pitchFamily="34" charset="-120"/>
               </a:rPr>
-              <a:t>SeneNews · 20/10 21h UTC · niveau élevé · Non confirmé</a:t>
+              <a:t>Africanews — Chaine panafricaine · 21/10 07h UTC · niveau élevé · Probable</a:t>
             </a:r>
             <a:endParaRPr lang="en-US" sz="1300" dirty="0"/>
           </a:p>
@@ -7923,7 +8819,7 @@
                 <a:ea typeface="Calibri" pitchFamily="34" charset="-122"/>
                 <a:cs typeface="Calibri" pitchFamily="34" charset="-120"/>
               </a:rPr>
-              <a:t>Education: Le SELS/Authentique refuse de s'associer à la grève de 72 heures des enseignants</a:t>
+              <a:t>La grève générale de 72 heures au menu des quotidiens</a:t>
             </a:r>
             <a:endParaRPr lang="en-US" sz="1300" dirty="0"/>
           </a:p>
@@ -7943,7 +8839,7 @@
                 <a:ea typeface="Calibri" pitchFamily="34" charset="-122"/>
                 <a:cs typeface="Calibri" pitchFamily="34" charset="-120"/>
               </a:rPr>
-              <a:t>Pressafrik · 20/10 20h UTC · niveau élevé · Probable</a:t>
+              <a:t>APS — Agence Sénégalaise Presse · 21/10 07h UTC · niveau élevé · Probable</a:t>
             </a:r>
             <a:endParaRPr lang="en-US" sz="1300" dirty="0"/>
           </a:p>
@@ -7992,7 +8888,7 @@
       </p:sp>
       <p:sp>
         <p:nvSpPr>
-          <p:cNvPr id="7" name="Shape 5"/>
+          <p:cNvPr id="11" name="Shape 9"/>
           <p:cNvSpPr/>
           <p:nvPr/>
         </p:nvSpPr>
@@ -8017,7 +8913,7 @@
       </p:sp>
       <p:sp>
         <p:nvSpPr>
-          <p:cNvPr id="8" name="Text 6"/>
+          <p:cNvPr id="12" name="Text 10"/>
           <p:cNvSpPr/>
           <p:nvPr/>
         </p:nvSpPr>
@@ -8056,7 +8952,7 @@
       </p:sp>
       <p:sp>
         <p:nvSpPr>
-          <p:cNvPr id="9" name="Text 7"/>
+          <p:cNvPr id="13" name="Text 11"/>
           <p:cNvSpPr/>
           <p:nvPr/>
         </p:nvSpPr>
@@ -8091,7 +8987,7 @@
                 <a:ea typeface="Calibri" pitchFamily="34" charset="-122"/>
                 <a:cs typeface="Calibri" pitchFamily="34" charset="-120"/>
               </a:rPr>
-              <a:t>Niveau jaune (modéré, 31.3/100), confiance moyenne.</a:t>
+              <a:t>Niveau orange (élevé, 36.8/100), confiance moyenne.</a:t>
             </a:r>
             <a:endParaRPr lang="en-US" sz="1200" dirty="0"/>
           </a:p>
@@ -8133,7 +9029,7 @@
                 <a:ea typeface="Calibri" pitchFamily="34" charset="-122"/>
                 <a:cs typeface="Calibri" pitchFamily="34" charset="-120"/>
               </a:rPr>
-              <a:t>Niveau en baisse de 1 cran depuis le 2026-09-12.</a:t>
+              <a:t>Niveau stable depuis le 2026-09-12.</a:t>
             </a:r>
             <a:endParaRPr lang="en-US" sz="1200" dirty="0"/>
           </a:p>
@@ -8162,7 +9058,7 @@
       </p:sp>
       <p:pic>
         <p:nvPicPr>
-          <p:cNvPr id="10" name="Image 0" descr="/home/runner/work/SentiqS/SentiqS/scripts/assets/grsci/logo-grsci.png">    </p:cNvPr>
+          <p:cNvPr id="14" name="Image 0" descr="/home/runner/work/SentiqS/SentiqS/scripts/assets/grsci/logo-grsci.png">    </p:cNvPr>
           <p:cNvPicPr>
             <a:picLocks noChangeAspect="1"/>
           </p:cNvPicPr>
@@ -8186,7 +9082,7 @@
       </p:pic>
       <p:sp>
         <p:nvSpPr>
-          <p:cNvPr id="11" name="Text 8"/>
+          <p:cNvPr id="15" name="Text 12"/>
           <p:cNvSpPr/>
           <p:nvPr/>
         </p:nvSpPr>
@@ -8355,7 +9251,7 @@
       </p:sp>
       <p:sp>
         <p:nvSpPr>
-          <p:cNvPr id="12" name="Text 9"/>
+          <p:cNvPr id="16" name="Text 13"/>
           <p:cNvSpPr/>
           <p:nvPr/>
         </p:nvSpPr>
@@ -8444,17 +9340,17 @@
               <a:buNone/>
             </a:pPr>
             <a:r>
-              <a:rPr lang="en-US" sz="2200" b="1" dirty="0">
+              <a:rPr lang="en-US" sz="2400" dirty="0">
                 <a:solidFill>
                   <a:srgbClr val="FFFFFF"/>
                 </a:solidFill>
-                <a:latin typeface="Calibri" pitchFamily="34" charset="0"/>
-                <a:ea typeface="Calibri" pitchFamily="34" charset="-122"/>
-                <a:cs typeface="Calibri" pitchFamily="34" charset="-120"/>
+                <a:latin typeface="Arial Narrow" pitchFamily="34" charset="0"/>
+                <a:ea typeface="Arial Narrow" pitchFamily="34" charset="-122"/>
+                <a:cs typeface="Arial Narrow" pitchFamily="34" charset="-120"/>
               </a:rPr>
               <a:t>V</a:t>
             </a:r>
-            <a:endParaRPr lang="en-US" sz="2200" dirty="0"/>
+            <a:endParaRPr lang="en-US" sz="2400" dirty="0"/>
           </a:p>
         </p:txBody>
       </p:sp>
@@ -8483,13 +9379,13 @@
               <a:buNone/>
             </a:pPr>
             <a:r>
-              <a:rPr lang="en-US" sz="2800" b="1" dirty="0">
+              <a:rPr lang="en-US" sz="2800" u="sng" dirty="0">
                 <a:solidFill>
                   <a:srgbClr val="1F6B5E"/>
                 </a:solidFill>
-                <a:latin typeface="Calibri" pitchFamily="34" charset="0"/>
-                <a:ea typeface="Calibri" pitchFamily="34" charset="-122"/>
-                <a:cs typeface="Calibri" pitchFamily="34" charset="-120"/>
+                <a:latin typeface="Arial Narrow" pitchFamily="34" charset="0"/>
+                <a:ea typeface="Arial Narrow" pitchFamily="34" charset="-122"/>
+                <a:cs typeface="Arial Narrow" pitchFamily="34" charset="-120"/>
               </a:rPr>
               <a:t>CE QUE NOUS NE SAVONS PAS</a:t>
             </a:r>
@@ -9075,17 +9971,17 @@
               <a:buNone/>
             </a:pPr>
             <a:r>
-              <a:rPr lang="en-US" sz="2200" b="1" dirty="0">
+              <a:rPr lang="en-US" sz="2400" dirty="0">
                 <a:solidFill>
                   <a:srgbClr val="FFFFFF"/>
                 </a:solidFill>
-                <a:latin typeface="Calibri" pitchFamily="34" charset="0"/>
-                <a:ea typeface="Calibri" pitchFamily="34" charset="-122"/>
-                <a:cs typeface="Calibri" pitchFamily="34" charset="-120"/>
+                <a:latin typeface="Arial Narrow" pitchFamily="34" charset="0"/>
+                <a:ea typeface="Arial Narrow" pitchFamily="34" charset="-122"/>
+                <a:cs typeface="Arial Narrow" pitchFamily="34" charset="-120"/>
               </a:rPr>
               <a:t>0</a:t>
             </a:r>
-            <a:endParaRPr lang="en-US" sz="2200" dirty="0"/>
+            <a:endParaRPr lang="en-US" sz="2400" dirty="0"/>
           </a:p>
         </p:txBody>
       </p:sp>
@@ -9114,13 +10010,13 @@
               <a:buNone/>
             </a:pPr>
             <a:r>
-              <a:rPr lang="en-US" sz="2800" b="1" dirty="0">
+              <a:rPr lang="en-US" sz="2800" u="sng" dirty="0">
                 <a:solidFill>
                   <a:srgbClr val="1F6B5E"/>
                 </a:solidFill>
-                <a:latin typeface="Calibri" pitchFamily="34" charset="0"/>
-                <a:ea typeface="Calibri" pitchFamily="34" charset="-122"/>
-                <a:cs typeface="Calibri" pitchFamily="34" charset="-120"/>
+                <a:latin typeface="Arial Narrow" pitchFamily="34" charset="0"/>
+                <a:ea typeface="Arial Narrow" pitchFamily="34" charset="-122"/>
+                <a:cs typeface="Arial Narrow" pitchFamily="34" charset="-120"/>
               </a:rPr>
               <a:t>TABLE DES MATIÈRES</a:t>
             </a:r>
@@ -9440,7 +10336,7 @@
                 <a:ea typeface="Calibri" pitchFamily="34" charset="-122"/>
                 <a:cs typeface="Calibri" pitchFamily="34" charset="-120"/>
               </a:rPr>
-              <a:t>ROUGE · confiance moyenne · 4 fait(s)</a:t>
+              <a:t>ROUGE · confiance moyenne · 7 fait(s)</a:t>
             </a:r>
             <a:endParaRPr lang="en-US" sz="1100" dirty="0"/>
           </a:p>
@@ -9481,7 +10377,7 @@
                 <a:ea typeface="Calibri" pitchFamily="34" charset="-122"/>
                 <a:cs typeface="Calibri" pitchFamily="34" charset="-120"/>
               </a:rPr>
-              <a:t>ROUGE · confiance moyenne · 12 fait(s)</a:t>
+              <a:t>ROUGE · confiance faible · 9 fait(s)</a:t>
             </a:r>
             <a:endParaRPr lang="en-US" sz="1100" dirty="0"/>
           </a:p>
@@ -9522,7 +10418,7 @@
                 <a:ea typeface="Calibri" pitchFamily="34" charset="-122"/>
                 <a:cs typeface="Calibri" pitchFamily="34" charset="-120"/>
               </a:rPr>
-              <a:t>MARRON · confiance moyenne · 2 fait(s)</a:t>
+              <a:t>MARRON · confiance moyenne · 1 fait(s)</a:t>
             </a:r>
             <a:endParaRPr lang="en-US" sz="1100" dirty="0"/>
           </a:p>
@@ -9563,7 +10459,7 @@
                 <a:ea typeface="Calibri" pitchFamily="34" charset="-122"/>
                 <a:cs typeface="Calibri" pitchFamily="34" charset="-120"/>
               </a:rPr>
-              <a:t>ORANGE · confiance faible · 1 fait(s)</a:t>
+              <a:t>ORANGE · confiance faible · 2 fait(s)</a:t>
             </a:r>
             <a:endParaRPr lang="en-US" sz="1100" dirty="0"/>
           </a:p>
@@ -9604,7 +10500,7 @@
                 <a:ea typeface="Calibri" pitchFamily="34" charset="-122"/>
                 <a:cs typeface="Calibri" pitchFamily="34" charset="-120"/>
               </a:rPr>
-              <a:t>ORANGE · confiance faible · 3 fait(s)</a:t>
+              <a:t>ORANGE · confiance faible · 5 fait(s)</a:t>
             </a:r>
             <a:endParaRPr lang="en-US" sz="1100" dirty="0"/>
           </a:p>
@@ -9686,7 +10582,7 @@
                 <a:ea typeface="Calibri" pitchFamily="34" charset="-122"/>
                 <a:cs typeface="Calibri" pitchFamily="34" charset="-120"/>
               </a:rPr>
-              <a:t>JAUNE · confiance faible · 5 fait(s)</a:t>
+              <a:t>JAUNE · confiance faible · 4 fait(s)</a:t>
             </a:r>
             <a:endParaRPr lang="en-US" sz="1100" dirty="0"/>
           </a:p>
@@ -9727,7 +10623,7 @@
                 <a:ea typeface="Calibri" pitchFamily="34" charset="-122"/>
                 <a:cs typeface="Calibri" pitchFamily="34" charset="-120"/>
               </a:rPr>
-              <a:t>JAUNE · confiance faible · 1 fait(s)</a:t>
+              <a:t>JAUNE · confiance faible · 0 fait(s)</a:t>
             </a:r>
             <a:endParaRPr lang="en-US" sz="1100" dirty="0"/>
           </a:p>
@@ -9768,7 +10664,7 @@
                 <a:ea typeface="Calibri" pitchFamily="34" charset="-122"/>
                 <a:cs typeface="Calibri" pitchFamily="34" charset="-120"/>
               </a:rPr>
-              <a:t>JAUNE · confiance moyenne · 12 fait(s)</a:t>
+              <a:t>ORANGE · confiance moyenne · 12 fait(s)</a:t>
             </a:r>
             <a:endParaRPr lang="en-US" sz="1100" dirty="0"/>
           </a:p>
@@ -10020,7 +10916,7 @@
     <p:bg>
       <p:bgPr>
         <a:solidFill>
-          <a:srgbClr val="CCCCCC"/>
+          <a:srgbClr val="CDCDCD"/>
         </a:solidFill>
       </p:bgPr>
     </p:bg>
@@ -10038,9 +10934,33 @@
           <a:chExt cx="0" cy="0"/>
         </a:xfrm>
       </p:grpSpPr>
-      <p:sp>
-        <p:nvSpPr>
-          <p:cNvPr id="2" name="Text 0"/>
+      <p:pic>
+        <p:nvPicPr>
+          <p:cNvPr id="2" name="Image 0" descr="/home/runner/work/SentiqS/SentiqS/scripts/assets/grsci/carte-ci.jpg">    </p:cNvPr>
+          <p:cNvPicPr>
+            <a:picLocks noChangeAspect="1"/>
+          </p:cNvPicPr>
+          <p:nvPr/>
+        </p:nvPicPr>
+        <p:blipFill>
+          <a:blip r:embed="rId1"/>
+          <a:stretch>
+            <a:fillRect/>
+          </a:stretch>
+        </p:blipFill>
+        <p:spPr>
+          <a:xfrm>
+            <a:off x="4754880" y="640080"/>
+            <a:ext cx="2926080" cy="2926080"/>
+          </a:xfrm>
+          <a:prstGeom prst="rect">
+            <a:avLst/>
+          </a:prstGeom>
+        </p:spPr>
+      </p:pic>
+      <p:sp>
+        <p:nvSpPr>
+          <p:cNvPr id="3" name="Text 0"/>
           <p:cNvSpPr/>
           <p:nvPr/>
         </p:nvSpPr>
@@ -10063,23 +10983,23 @@
               <a:buNone/>
             </a:pPr>
             <a:r>
-              <a:rPr lang="en-US" sz="4000" b="1" dirty="0">
+              <a:rPr lang="en-US" sz="4400" dirty="0">
                 <a:solidFill>
                   <a:srgbClr val="111111"/>
                 </a:solidFill>
-                <a:latin typeface="Calibri" pitchFamily="34" charset="0"/>
-                <a:ea typeface="Calibri" pitchFamily="34" charset="-122"/>
-                <a:cs typeface="Calibri" pitchFamily="34" charset="-120"/>
+                <a:latin typeface="Arial Narrow" pitchFamily="34" charset="0"/>
+                <a:ea typeface="Arial Narrow" pitchFamily="34" charset="-122"/>
+                <a:cs typeface="Arial Narrow" pitchFamily="34" charset="-120"/>
               </a:rPr>
               <a:t>FAITS MARQUANTS EN CÔTE D'IVOIRE</a:t>
             </a:r>
-            <a:endParaRPr lang="en-US" sz="4000" dirty="0"/>
+            <a:endParaRPr lang="en-US" sz="4400" dirty="0"/>
           </a:p>
         </p:txBody>
       </p:sp>
       <p:sp>
         <p:nvSpPr>
-          <p:cNvPr id="3" name="Shape 1"/>
+          <p:cNvPr id="4" name="Shape 1"/>
           <p:cNvSpPr/>
           <p:nvPr/>
         </p:nvSpPr>
@@ -10102,14 +11022,14 @@
       </p:sp>
       <p:pic>
         <p:nvPicPr>
-          <p:cNvPr id="4" name="Image 0" descr="/home/runner/work/SentiqS/SentiqS/scripts/assets/grsci/logo-grsci.png">    </p:cNvPr>
+          <p:cNvPr id="5" name="Image 1" descr="/home/runner/work/SentiqS/SentiqS/scripts/assets/grsci/logo-grsci.png">    </p:cNvPr>
           <p:cNvPicPr>
             <a:picLocks noChangeAspect="1"/>
           </p:cNvPicPr>
           <p:nvPr/>
         </p:nvPicPr>
         <p:blipFill>
-          <a:blip r:embed="rId1"/>
+          <a:blip r:embed="rId2"/>
           <a:stretch>
             <a:fillRect/>
           </a:stretch>
@@ -10126,7 +11046,7 @@
       </p:pic>
       <p:sp>
         <p:nvSpPr>
-          <p:cNvPr id="5" name="Text 2"/>
+          <p:cNvPr id="6" name="Text 2"/>
           <p:cNvSpPr/>
           <p:nvPr/>
         </p:nvSpPr>
@@ -10295,7 +11215,7 @@
       </p:sp>
       <p:sp>
         <p:nvSpPr>
-          <p:cNvPr id="6" name="Text 3"/>
+          <p:cNvPr id="7" name="Text 3"/>
           <p:cNvSpPr/>
           <p:nvPr/>
         </p:nvSpPr>
@@ -10384,17 +11304,17 @@
               <a:buNone/>
             </a:pPr>
             <a:r>
-              <a:rPr lang="en-US" sz="2200" b="1" dirty="0">
+              <a:rPr lang="en-US" sz="2400" dirty="0">
                 <a:solidFill>
                   <a:srgbClr val="FFFFFF"/>
                 </a:solidFill>
-                <a:latin typeface="Calibri" pitchFamily="34" charset="0"/>
-                <a:ea typeface="Calibri" pitchFamily="34" charset="-122"/>
-                <a:cs typeface="Calibri" pitchFamily="34" charset="-120"/>
+                <a:latin typeface="Arial Narrow" pitchFamily="34" charset="0"/>
+                <a:ea typeface="Arial Narrow" pitchFamily="34" charset="-122"/>
+                <a:cs typeface="Arial Narrow" pitchFamily="34" charset="-120"/>
               </a:rPr>
               <a:t>0</a:t>
             </a:r>
-            <a:endParaRPr lang="en-US" sz="2200" dirty="0"/>
+            <a:endParaRPr lang="en-US" sz="2400" dirty="0"/>
           </a:p>
         </p:txBody>
       </p:sp>
@@ -10423,13 +11343,13 @@
               <a:buNone/>
             </a:pPr>
             <a:r>
-              <a:rPr lang="en-US" sz="2800" b="1" dirty="0">
+              <a:rPr lang="en-US" sz="2800" u="sng" dirty="0">
                 <a:solidFill>
                   <a:srgbClr val="1F6B5E"/>
                 </a:solidFill>
-                <a:latin typeface="Calibri" pitchFamily="34" charset="0"/>
-                <a:ea typeface="Calibri" pitchFamily="34" charset="-122"/>
-                <a:cs typeface="Calibri" pitchFamily="34" charset="-120"/>
+                <a:latin typeface="Arial Narrow" pitchFamily="34" charset="0"/>
+                <a:ea typeface="Arial Narrow" pitchFamily="34" charset="-122"/>
+                <a:cs typeface="Arial Narrow" pitchFamily="34" charset="-120"/>
               </a:rPr>
               <a:t>EN BREF — CÔTE D'IVOIRE</a:t>
             </a:r>
@@ -10454,6 +11374,78 @@
           <a:solidFill>
             <a:srgbClr val="F77F00"/>
           </a:solidFill>
+          <a:ln w="12700">
+            <a:solidFill>
+              <a:srgbClr val="F77F00"/>
+            </a:solidFill>
+            <a:prstDash val="solid"/>
+          </a:ln>
+        </p:spPr>
+      </p:sp>
+      <p:sp>
+        <p:nvSpPr>
+          <p:cNvPr id="5" name="Shape 3"/>
+          <p:cNvSpPr/>
+          <p:nvPr/>
+        </p:nvSpPr>
+        <p:spPr>
+          <a:xfrm>
+            <a:off x="11183112" y="274320"/>
+            <a:ext cx="301752" cy="566928"/>
+          </a:xfrm>
+          <a:prstGeom prst="rect">
+            <a:avLst/>
+          </a:prstGeom>
+          <a:solidFill>
+            <a:srgbClr val="FFFFFF"/>
+          </a:solidFill>
+          <a:ln w="12700">
+            <a:solidFill>
+              <a:srgbClr val="FFFFFF"/>
+            </a:solidFill>
+            <a:prstDash val="solid"/>
+          </a:ln>
+        </p:spPr>
+      </p:sp>
+      <p:sp>
+        <p:nvSpPr>
+          <p:cNvPr id="6" name="Shape 4"/>
+          <p:cNvSpPr/>
+          <p:nvPr/>
+        </p:nvSpPr>
+        <p:spPr>
+          <a:xfrm>
+            <a:off x="11484864" y="274320"/>
+            <a:ext cx="301752" cy="566928"/>
+          </a:xfrm>
+          <a:prstGeom prst="rect">
+            <a:avLst/>
+          </a:prstGeom>
+          <a:solidFill>
+            <a:srgbClr val="009E60"/>
+          </a:solidFill>
+          <a:ln w="12700">
+            <a:solidFill>
+              <a:srgbClr val="009E60"/>
+            </a:solidFill>
+            <a:prstDash val="solid"/>
+          </a:ln>
+        </p:spPr>
+      </p:sp>
+      <p:sp>
+        <p:nvSpPr>
+          <p:cNvPr id="7" name="Shape 5"/>
+          <p:cNvSpPr/>
+          <p:nvPr/>
+        </p:nvSpPr>
+        <p:spPr>
+          <a:xfrm>
+            <a:off x="10881360" y="274320"/>
+            <a:ext cx="905256" cy="566928"/>
+          </a:xfrm>
+          <a:prstGeom prst="rect">
+            <a:avLst/>
+          </a:prstGeom>
           <a:ln w="6350">
             <a:solidFill>
               <a:srgbClr val="1F2937"/>
@@ -10464,57 +11456,7 @@
       </p:sp>
       <p:sp>
         <p:nvSpPr>
-          <p:cNvPr id="5" name="Shape 3"/>
-          <p:cNvSpPr/>
-          <p:nvPr/>
-        </p:nvSpPr>
-        <p:spPr>
-          <a:xfrm>
-            <a:off x="11183112" y="274320"/>
-            <a:ext cx="301752" cy="566928"/>
-          </a:xfrm>
-          <a:prstGeom prst="rect">
-            <a:avLst/>
-          </a:prstGeom>
-          <a:solidFill>
-            <a:srgbClr val="FFFFFF"/>
-          </a:solidFill>
-          <a:ln w="6350">
-            <a:solidFill>
-              <a:srgbClr val="1F2937"/>
-            </a:solidFill>
-            <a:prstDash val="solid"/>
-          </a:ln>
-        </p:spPr>
-      </p:sp>
-      <p:sp>
-        <p:nvSpPr>
-          <p:cNvPr id="6" name="Shape 4"/>
-          <p:cNvSpPr/>
-          <p:nvPr/>
-        </p:nvSpPr>
-        <p:spPr>
-          <a:xfrm>
-            <a:off x="11484864" y="274320"/>
-            <a:ext cx="301752" cy="566928"/>
-          </a:xfrm>
-          <a:prstGeom prst="rect">
-            <a:avLst/>
-          </a:prstGeom>
-          <a:solidFill>
-            <a:srgbClr val="009E60"/>
-          </a:solidFill>
-          <a:ln w="6350">
-            <a:solidFill>
-              <a:srgbClr val="1F2937"/>
-            </a:solidFill>
-            <a:prstDash val="solid"/>
-          </a:ln>
-        </p:spPr>
-      </p:sp>
-      <p:sp>
-        <p:nvSpPr>
-          <p:cNvPr id="7" name="Shape 5"/>
+          <p:cNvPr id="8" name="Shape 6"/>
           <p:cNvSpPr/>
           <p:nvPr/>
         </p:nvSpPr>
@@ -10537,7 +11479,7 @@
       </p:sp>
       <p:sp>
         <p:nvSpPr>
-          <p:cNvPr id="8" name="Text 6"/>
+          <p:cNvPr id="9" name="Text 7"/>
           <p:cNvSpPr/>
           <p:nvPr/>
         </p:nvSpPr>
@@ -10578,7 +11520,7 @@
       </p:sp>
       <p:sp>
         <p:nvSpPr>
-          <p:cNvPr id="9" name="Text 7"/>
+          <p:cNvPr id="10" name="Text 8"/>
           <p:cNvSpPr/>
           <p:nvPr/>
         </p:nvSpPr>
@@ -10609,7 +11551,7 @@
                 <a:ea typeface="Calibri" pitchFamily="34" charset="-122"/>
                 <a:cs typeface="Calibri" pitchFamily="34" charset="-120"/>
               </a:rPr>
-              <a:t>Niveau modéré · score 25.3/100</a:t>
+              <a:t>Niveau modéré · score 18.8/100</a:t>
             </a:r>
             <a:endParaRPr lang="en-US" sz="1600" dirty="0"/>
           </a:p>
@@ -10626,7 +11568,7 @@
                 <a:ea typeface="Calibri" pitchFamily="34" charset="-122"/>
                 <a:cs typeface="Calibri" pitchFamily="34" charset="-120"/>
               </a:rPr>
-              <a:t>Confiance moyenne — incident vérifié le plus récent : 113 jours ; 1 signal du jour</a:t>
+              <a:t>Confiance faible — incident vérifié le plus récent : 114 jours ; aucun signal du jour</a:t>
             </a:r>
             <a:endParaRPr lang="en-US" sz="1600" dirty="0"/>
           </a:p>
@@ -10651,7 +11593,7 @@
       </p:sp>
       <p:sp>
         <p:nvSpPr>
-          <p:cNvPr id="10" name="Text 8"/>
+          <p:cNvPr id="11" name="Text 9"/>
           <p:cNvSpPr/>
           <p:nvPr/>
         </p:nvSpPr>
@@ -10690,7 +11632,7 @@
       </p:sp>
       <p:sp>
         <p:nvSpPr>
-          <p:cNvPr id="11" name="Text 9"/>
+          <p:cNvPr id="12" name="Text 10"/>
           <p:cNvSpPr/>
           <p:nvPr/>
         </p:nvSpPr>
@@ -10725,7 +11667,7 @@
                 <a:ea typeface="Calibri" pitchFamily="34" charset="-122"/>
                 <a:cs typeface="Calibri" pitchFamily="34" charset="-120"/>
               </a:rPr>
-              <a:t>Renforcement securitaire preventif regions nord Hambol/Poro — 29/06/2026 06h00 (113 j)</a:t>
+              <a:t>Renforcement securitaire preventif regions nord Hambol/Poro — 29/06/2026 06h00 (114 j)</a:t>
             </a:r>
             <a:endParaRPr lang="en-US" sz="1200" dirty="0"/>
           </a:p>
@@ -10754,7 +11696,7 @@
       </p:sp>
       <p:sp>
         <p:nvSpPr>
-          <p:cNvPr id="12" name="Shape 10"/>
+          <p:cNvPr id="13" name="Shape 11"/>
           <p:cNvSpPr/>
           <p:nvPr/>
         </p:nvSpPr>
@@ -10779,7 +11721,7 @@
       </p:sp>
       <p:sp>
         <p:nvSpPr>
-          <p:cNvPr id="13" name="Text 11"/>
+          <p:cNvPr id="14" name="Text 12"/>
           <p:cNvSpPr/>
           <p:nvPr/>
         </p:nvSpPr>
@@ -10818,7 +11760,7 @@
       </p:sp>
       <p:sp>
         <p:nvSpPr>
-          <p:cNvPr id="14" name="Text 12"/>
+          <p:cNvPr id="15" name="Text 13"/>
           <p:cNvSpPr/>
           <p:nvPr/>
         </p:nvSpPr>
@@ -10853,7 +11795,7 @@
                 <a:ea typeface="Calibri" pitchFamily="34" charset="-122"/>
                 <a:cs typeface="Calibri" pitchFamily="34" charset="-120"/>
               </a:rPr>
-              <a:t>Niveau jaune (modéré, 25.3/100), confiance moyenne.</a:t>
+              <a:t>Niveau jaune (modéré, 18.8/100), confiance faible.</a:t>
             </a:r>
             <a:endParaRPr lang="en-US" sz="1200" dirty="0"/>
           </a:p>
@@ -10874,7 +11816,7 @@
                 <a:ea typeface="Calibri" pitchFamily="34" charset="-122"/>
                 <a:cs typeface="Calibri" pitchFamily="34" charset="-120"/>
               </a:rPr>
-              <a:t>Fondement : incident vérifié le plus récent : 113 jours ; 1 signal du jour.</a:t>
+              <a:t>Fondement : incident vérifié le plus récent : 114 jours ; aucun signal du jour.</a:t>
             </a:r>
             <a:endParaRPr lang="en-US" sz="1200" dirty="0"/>
           </a:p>
@@ -10924,7 +11866,7 @@
       </p:sp>
       <p:pic>
         <p:nvPicPr>
-          <p:cNvPr id="15" name="Image 0" descr="/home/runner/work/SentiqS/SentiqS/scripts/assets/grsci/logo-grsci.png">    </p:cNvPr>
+          <p:cNvPr id="16" name="Image 0" descr="/home/runner/work/SentiqS/SentiqS/scripts/assets/grsci/logo-grsci.png">    </p:cNvPr>
           <p:cNvPicPr>
             <a:picLocks noChangeAspect="1"/>
           </p:cNvPicPr>
@@ -10948,7 +11890,7 @@
       </p:pic>
       <p:sp>
         <p:nvSpPr>
-          <p:cNvPr id="16" name="Text 13"/>
+          <p:cNvPr id="17" name="Text 14"/>
           <p:cNvSpPr/>
           <p:nvPr/>
         </p:nvSpPr>
@@ -11117,7 +12059,7 @@
       </p:sp>
       <p:sp>
         <p:nvSpPr>
-          <p:cNvPr id="17" name="Text 14"/>
+          <p:cNvPr id="18" name="Text 15"/>
           <p:cNvSpPr/>
           <p:nvPr/>
         </p:nvSpPr>
@@ -11206,17 +12148,17 @@
               <a:buNone/>
             </a:pPr>
             <a:r>
-              <a:rPr lang="en-US" sz="2200" b="1" dirty="0">
+              <a:rPr lang="en-US" sz="2400" dirty="0">
                 <a:solidFill>
                   <a:srgbClr val="FFFFFF"/>
                 </a:solidFill>
-                <a:latin typeface="Calibri" pitchFamily="34" charset="0"/>
-                <a:ea typeface="Calibri" pitchFamily="34" charset="-122"/>
-                <a:cs typeface="Calibri" pitchFamily="34" charset="-120"/>
+                <a:latin typeface="Arial Narrow" pitchFamily="34" charset="0"/>
+                <a:ea typeface="Arial Narrow" pitchFamily="34" charset="-122"/>
+                <a:cs typeface="Arial Narrow" pitchFamily="34" charset="-120"/>
               </a:rPr>
               <a:t>I</a:t>
             </a:r>
-            <a:endParaRPr lang="en-US" sz="2200" dirty="0"/>
+            <a:endParaRPr lang="en-US" sz="2400" dirty="0"/>
           </a:p>
         </p:txBody>
       </p:sp>
@@ -11245,15 +12187,15 @@
               <a:buNone/>
             </a:pPr>
             <a:r>
-              <a:rPr lang="en-US" sz="2800" b="1" dirty="0">
+              <a:rPr lang="en-US" sz="2800" u="sng" dirty="0">
                 <a:solidFill>
                   <a:srgbClr val="1F6B5E"/>
                 </a:solidFill>
-                <a:latin typeface="Calibri" pitchFamily="34" charset="0"/>
-                <a:ea typeface="Calibri" pitchFamily="34" charset="-122"/>
-                <a:cs typeface="Calibri" pitchFamily="34" charset="-120"/>
-              </a:rPr>
-              <a:t>POLITIQUE</a:t>
+                <a:latin typeface="Arial Narrow" pitchFamily="34" charset="0"/>
+                <a:ea typeface="Arial Narrow" pitchFamily="34" charset="-122"/>
+                <a:cs typeface="Arial Narrow" pitchFamily="34" charset="-120"/>
+              </a:rPr>
+              <a:t>- POLITIQUE</a:t>
             </a:r>
             <a:endParaRPr lang="en-US" sz="2800" dirty="0"/>
           </a:p>
@@ -11276,6 +12218,78 @@
           <a:solidFill>
             <a:srgbClr val="F77F00"/>
           </a:solidFill>
+          <a:ln w="12700">
+            <a:solidFill>
+              <a:srgbClr val="F77F00"/>
+            </a:solidFill>
+            <a:prstDash val="solid"/>
+          </a:ln>
+        </p:spPr>
+      </p:sp>
+      <p:sp>
+        <p:nvSpPr>
+          <p:cNvPr id="5" name="Shape 3"/>
+          <p:cNvSpPr/>
+          <p:nvPr/>
+        </p:nvSpPr>
+        <p:spPr>
+          <a:xfrm>
+            <a:off x="11183112" y="274320"/>
+            <a:ext cx="301752" cy="566928"/>
+          </a:xfrm>
+          <a:prstGeom prst="rect">
+            <a:avLst/>
+          </a:prstGeom>
+          <a:solidFill>
+            <a:srgbClr val="FFFFFF"/>
+          </a:solidFill>
+          <a:ln w="12700">
+            <a:solidFill>
+              <a:srgbClr val="FFFFFF"/>
+            </a:solidFill>
+            <a:prstDash val="solid"/>
+          </a:ln>
+        </p:spPr>
+      </p:sp>
+      <p:sp>
+        <p:nvSpPr>
+          <p:cNvPr id="6" name="Shape 4"/>
+          <p:cNvSpPr/>
+          <p:nvPr/>
+        </p:nvSpPr>
+        <p:spPr>
+          <a:xfrm>
+            <a:off x="11484864" y="274320"/>
+            <a:ext cx="301752" cy="566928"/>
+          </a:xfrm>
+          <a:prstGeom prst="rect">
+            <a:avLst/>
+          </a:prstGeom>
+          <a:solidFill>
+            <a:srgbClr val="009E60"/>
+          </a:solidFill>
+          <a:ln w="12700">
+            <a:solidFill>
+              <a:srgbClr val="009E60"/>
+            </a:solidFill>
+            <a:prstDash val="solid"/>
+          </a:ln>
+        </p:spPr>
+      </p:sp>
+      <p:sp>
+        <p:nvSpPr>
+          <p:cNvPr id="7" name="Shape 5"/>
+          <p:cNvSpPr/>
+          <p:nvPr/>
+        </p:nvSpPr>
+        <p:spPr>
+          <a:xfrm>
+            <a:off x="10881360" y="274320"/>
+            <a:ext cx="905256" cy="566928"/>
+          </a:xfrm>
+          <a:prstGeom prst="rect">
+            <a:avLst/>
+          </a:prstGeom>
           <a:ln w="6350">
             <a:solidFill>
               <a:srgbClr val="1F2937"/>
@@ -11286,57 +12300,7 @@
       </p:sp>
       <p:sp>
         <p:nvSpPr>
-          <p:cNvPr id="5" name="Shape 3"/>
-          <p:cNvSpPr/>
-          <p:nvPr/>
-        </p:nvSpPr>
-        <p:spPr>
-          <a:xfrm>
-            <a:off x="11183112" y="274320"/>
-            <a:ext cx="301752" cy="566928"/>
-          </a:xfrm>
-          <a:prstGeom prst="rect">
-            <a:avLst/>
-          </a:prstGeom>
-          <a:solidFill>
-            <a:srgbClr val="FFFFFF"/>
-          </a:solidFill>
-          <a:ln w="6350">
-            <a:solidFill>
-              <a:srgbClr val="1F2937"/>
-            </a:solidFill>
-            <a:prstDash val="solid"/>
-          </a:ln>
-        </p:spPr>
-      </p:sp>
-      <p:sp>
-        <p:nvSpPr>
-          <p:cNvPr id="6" name="Shape 4"/>
-          <p:cNvSpPr/>
-          <p:nvPr/>
-        </p:nvSpPr>
-        <p:spPr>
-          <a:xfrm>
-            <a:off x="11484864" y="274320"/>
-            <a:ext cx="301752" cy="566928"/>
-          </a:xfrm>
-          <a:prstGeom prst="rect">
-            <a:avLst/>
-          </a:prstGeom>
-          <a:solidFill>
-            <a:srgbClr val="009E60"/>
-          </a:solidFill>
-          <a:ln w="6350">
-            <a:solidFill>
-              <a:srgbClr val="1F2937"/>
-            </a:solidFill>
-            <a:prstDash val="solid"/>
-          </a:ln>
-        </p:spPr>
-      </p:sp>
-      <p:sp>
-        <p:nvSpPr>
-          <p:cNvPr id="7" name="Shape 5"/>
+          <p:cNvPr id="8" name="Shape 6"/>
           <p:cNvSpPr/>
           <p:nvPr/>
         </p:nvSpPr>
@@ -11359,7 +12323,7 @@
       </p:sp>
       <p:sp>
         <p:nvSpPr>
-          <p:cNvPr id="8" name="Text 6"/>
+          <p:cNvPr id="9" name="Text 7"/>
           <p:cNvSpPr/>
           <p:nvPr/>
         </p:nvSpPr>
@@ -11398,7 +12362,7 @@
       </p:sp>
       <p:sp>
         <p:nvSpPr>
-          <p:cNvPr id="9" name="Text 7"/>
+          <p:cNvPr id="10" name="Text 8"/>
           <p:cNvSpPr/>
           <p:nvPr/>
         </p:nvSpPr>
@@ -11461,7 +12425,7 @@
       </p:sp>
       <p:pic>
         <p:nvPicPr>
-          <p:cNvPr id="10" name="Image 0" descr="/home/runner/work/SentiqS/SentiqS/scripts/assets/grsci/logo-grsci.png">    </p:cNvPr>
+          <p:cNvPr id="11" name="Image 0" descr="/home/runner/work/SentiqS/SentiqS/scripts/assets/grsci/logo-grsci.png">    </p:cNvPr>
           <p:cNvPicPr>
             <a:picLocks noChangeAspect="1"/>
           </p:cNvPicPr>
@@ -11485,7 +12449,7 @@
       </p:pic>
       <p:sp>
         <p:nvSpPr>
-          <p:cNvPr id="11" name="Text 8"/>
+          <p:cNvPr id="12" name="Text 9"/>
           <p:cNvSpPr/>
           <p:nvPr/>
         </p:nvSpPr>
@@ -11654,7 +12618,7 @@
       </p:sp>
       <p:sp>
         <p:nvSpPr>
-          <p:cNvPr id="12" name="Text 9"/>
+          <p:cNvPr id="13" name="Text 10"/>
           <p:cNvSpPr/>
           <p:nvPr/>
         </p:nvSpPr>
@@ -11743,17 +12707,17 @@
               <a:buNone/>
             </a:pPr>
             <a:r>
-              <a:rPr lang="en-US" sz="2200" b="1" dirty="0">
+              <a:rPr lang="en-US" sz="2400" dirty="0">
                 <a:solidFill>
                   <a:srgbClr val="FFFFFF"/>
                 </a:solidFill>
-                <a:latin typeface="Calibri" pitchFamily="34" charset="0"/>
-                <a:ea typeface="Calibri" pitchFamily="34" charset="-122"/>
-                <a:cs typeface="Calibri" pitchFamily="34" charset="-120"/>
+                <a:latin typeface="Arial Narrow" pitchFamily="34" charset="0"/>
+                <a:ea typeface="Arial Narrow" pitchFamily="34" charset="-122"/>
+                <a:cs typeface="Arial Narrow" pitchFamily="34" charset="-120"/>
               </a:rPr>
               <a:t>II</a:t>
             </a:r>
-            <a:endParaRPr lang="en-US" sz="2200" dirty="0"/>
+            <a:endParaRPr lang="en-US" sz="2400" dirty="0"/>
           </a:p>
         </p:txBody>
       </p:sp>
@@ -11782,15 +12746,15 @@
               <a:buNone/>
             </a:pPr>
             <a:r>
-              <a:rPr lang="en-US" sz="2800" b="1" dirty="0">
+              <a:rPr lang="en-US" sz="2800" u="sng" dirty="0">
                 <a:solidFill>
                   <a:srgbClr val="1F6B5E"/>
                 </a:solidFill>
-                <a:latin typeface="Calibri" pitchFamily="34" charset="0"/>
-                <a:ea typeface="Calibri" pitchFamily="34" charset="-122"/>
-                <a:cs typeface="Calibri" pitchFamily="34" charset="-120"/>
-              </a:rPr>
-              <a:t>SOCIAL ET HUMANITAIRE</a:t>
+                <a:latin typeface="Arial Narrow" pitchFamily="34" charset="0"/>
+                <a:ea typeface="Arial Narrow" pitchFamily="34" charset="-122"/>
+                <a:cs typeface="Arial Narrow" pitchFamily="34" charset="-120"/>
+              </a:rPr>
+              <a:t>- SOCIAL ET HUMANITAIRE</a:t>
             </a:r>
             <a:endParaRPr lang="en-US" sz="2800" dirty="0"/>
           </a:p>
@@ -11813,6 +12777,78 @@
           <a:solidFill>
             <a:srgbClr val="F77F00"/>
           </a:solidFill>
+          <a:ln w="12700">
+            <a:solidFill>
+              <a:srgbClr val="F77F00"/>
+            </a:solidFill>
+            <a:prstDash val="solid"/>
+          </a:ln>
+        </p:spPr>
+      </p:sp>
+      <p:sp>
+        <p:nvSpPr>
+          <p:cNvPr id="5" name="Shape 3"/>
+          <p:cNvSpPr/>
+          <p:nvPr/>
+        </p:nvSpPr>
+        <p:spPr>
+          <a:xfrm>
+            <a:off x="11183112" y="274320"/>
+            <a:ext cx="301752" cy="566928"/>
+          </a:xfrm>
+          <a:prstGeom prst="rect">
+            <a:avLst/>
+          </a:prstGeom>
+          <a:solidFill>
+            <a:srgbClr val="FFFFFF"/>
+          </a:solidFill>
+          <a:ln w="12700">
+            <a:solidFill>
+              <a:srgbClr val="FFFFFF"/>
+            </a:solidFill>
+            <a:prstDash val="solid"/>
+          </a:ln>
+        </p:spPr>
+      </p:sp>
+      <p:sp>
+        <p:nvSpPr>
+          <p:cNvPr id="6" name="Shape 4"/>
+          <p:cNvSpPr/>
+          <p:nvPr/>
+        </p:nvSpPr>
+        <p:spPr>
+          <a:xfrm>
+            <a:off x="11484864" y="274320"/>
+            <a:ext cx="301752" cy="566928"/>
+          </a:xfrm>
+          <a:prstGeom prst="rect">
+            <a:avLst/>
+          </a:prstGeom>
+          <a:solidFill>
+            <a:srgbClr val="009E60"/>
+          </a:solidFill>
+          <a:ln w="12700">
+            <a:solidFill>
+              <a:srgbClr val="009E60"/>
+            </a:solidFill>
+            <a:prstDash val="solid"/>
+          </a:ln>
+        </p:spPr>
+      </p:sp>
+      <p:sp>
+        <p:nvSpPr>
+          <p:cNvPr id="7" name="Shape 5"/>
+          <p:cNvSpPr/>
+          <p:nvPr/>
+        </p:nvSpPr>
+        <p:spPr>
+          <a:xfrm>
+            <a:off x="10881360" y="274320"/>
+            <a:ext cx="905256" cy="566928"/>
+          </a:xfrm>
+          <a:prstGeom prst="rect">
+            <a:avLst/>
+          </a:prstGeom>
           <a:ln w="6350">
             <a:solidFill>
               <a:srgbClr val="1F2937"/>
@@ -11823,57 +12859,7 @@
       </p:sp>
       <p:sp>
         <p:nvSpPr>
-          <p:cNvPr id="5" name="Shape 3"/>
-          <p:cNvSpPr/>
-          <p:nvPr/>
-        </p:nvSpPr>
-        <p:spPr>
-          <a:xfrm>
-            <a:off x="11183112" y="274320"/>
-            <a:ext cx="301752" cy="566928"/>
-          </a:xfrm>
-          <a:prstGeom prst="rect">
-            <a:avLst/>
-          </a:prstGeom>
-          <a:solidFill>
-            <a:srgbClr val="FFFFFF"/>
-          </a:solidFill>
-          <a:ln w="6350">
-            <a:solidFill>
-              <a:srgbClr val="1F2937"/>
-            </a:solidFill>
-            <a:prstDash val="solid"/>
-          </a:ln>
-        </p:spPr>
-      </p:sp>
-      <p:sp>
-        <p:nvSpPr>
-          <p:cNvPr id="6" name="Shape 4"/>
-          <p:cNvSpPr/>
-          <p:nvPr/>
-        </p:nvSpPr>
-        <p:spPr>
-          <a:xfrm>
-            <a:off x="11484864" y="274320"/>
-            <a:ext cx="301752" cy="566928"/>
-          </a:xfrm>
-          <a:prstGeom prst="rect">
-            <a:avLst/>
-          </a:prstGeom>
-          <a:solidFill>
-            <a:srgbClr val="009E60"/>
-          </a:solidFill>
-          <a:ln w="6350">
-            <a:solidFill>
-              <a:srgbClr val="1F2937"/>
-            </a:solidFill>
-            <a:prstDash val="solid"/>
-          </a:ln>
-        </p:spPr>
-      </p:sp>
-      <p:sp>
-        <p:nvSpPr>
-          <p:cNvPr id="7" name="Shape 5"/>
+          <p:cNvPr id="8" name="Shape 6"/>
           <p:cNvSpPr/>
           <p:nvPr/>
         </p:nvSpPr>
@@ -11896,7 +12882,7 @@
       </p:sp>
       <p:sp>
         <p:nvSpPr>
-          <p:cNvPr id="8" name="Text 6"/>
+          <p:cNvPr id="9" name="Text 7"/>
           <p:cNvSpPr/>
           <p:nvPr/>
         </p:nvSpPr>
@@ -11935,7 +12921,7 @@
       </p:sp>
       <p:sp>
         <p:nvSpPr>
-          <p:cNvPr id="9" name="Text 7"/>
+          <p:cNvPr id="10" name="Text 8"/>
           <p:cNvSpPr/>
           <p:nvPr/>
         </p:nvSpPr>
@@ -11998,7 +12984,7 @@
       </p:sp>
       <p:pic>
         <p:nvPicPr>
-          <p:cNvPr id="10" name="Image 0" descr="/home/runner/work/SentiqS/SentiqS/scripts/assets/grsci/logo-grsci.png">    </p:cNvPr>
+          <p:cNvPr id="11" name="Image 0" descr="/home/runner/work/SentiqS/SentiqS/scripts/assets/grsci/logo-grsci.png">    </p:cNvPr>
           <p:cNvPicPr>
             <a:picLocks noChangeAspect="1"/>
           </p:cNvPicPr>
@@ -12022,7 +13008,7 @@
       </p:pic>
       <p:sp>
         <p:nvSpPr>
-          <p:cNvPr id="11" name="Text 8"/>
+          <p:cNvPr id="12" name="Text 9"/>
           <p:cNvSpPr/>
           <p:nvPr/>
         </p:nvSpPr>
@@ -12191,7 +13177,7 @@
       </p:sp>
       <p:sp>
         <p:nvSpPr>
-          <p:cNvPr id="12" name="Text 9"/>
+          <p:cNvPr id="13" name="Text 10"/>
           <p:cNvSpPr/>
           <p:nvPr/>
         </p:nvSpPr>
@@ -12242,7 +13228,7 @@
     <p:bg>
       <p:bgPr>
         <a:solidFill>
-          <a:srgbClr val="CCCCCC"/>
+          <a:srgbClr val="CDCDCD"/>
         </a:solidFill>
       </p:bgPr>
     </p:bg>
@@ -12309,17 +13295,17 @@
               <a:buNone/>
             </a:pPr>
             <a:r>
-              <a:rPr lang="en-US" sz="4000" b="1" dirty="0">
+              <a:rPr lang="en-US" sz="4400" dirty="0">
                 <a:solidFill>
                   <a:srgbClr val="111111"/>
                 </a:solidFill>
-                <a:latin typeface="Calibri" pitchFamily="34" charset="0"/>
-                <a:ea typeface="Calibri" pitchFamily="34" charset="-122"/>
-                <a:cs typeface="Calibri" pitchFamily="34" charset="-120"/>
+                <a:latin typeface="Arial Narrow" pitchFamily="34" charset="0"/>
+                <a:ea typeface="Arial Narrow" pitchFamily="34" charset="-122"/>
+                <a:cs typeface="Arial Narrow" pitchFamily="34" charset="-120"/>
               </a:rPr>
               <a:t>DYNAMIQUES RÉGIONALES</a:t>
             </a:r>
-            <a:endParaRPr lang="en-US" sz="4000" dirty="0"/>
+            <a:endParaRPr lang="en-US" sz="4400" dirty="0"/>
           </a:p>
         </p:txBody>
       </p:sp>
@@ -12630,17 +13616,17 @@
               <a:buNone/>
             </a:pPr>
             <a:r>
-              <a:rPr lang="en-US" sz="2200" b="1" dirty="0">
+              <a:rPr lang="en-US" sz="2400" dirty="0">
                 <a:solidFill>
                   <a:srgbClr val="FFFFFF"/>
                 </a:solidFill>
-                <a:latin typeface="Calibri" pitchFamily="34" charset="0"/>
-                <a:ea typeface="Calibri" pitchFamily="34" charset="-122"/>
-                <a:cs typeface="Calibri" pitchFamily="34" charset="-120"/>
+                <a:latin typeface="Arial Narrow" pitchFamily="34" charset="0"/>
+                <a:ea typeface="Arial Narrow" pitchFamily="34" charset="-122"/>
+                <a:cs typeface="Arial Narrow" pitchFamily="34" charset="-120"/>
               </a:rPr>
               <a:t>I</a:t>
             </a:r>
-            <a:endParaRPr lang="en-US" sz="2200" dirty="0"/>
+            <a:endParaRPr lang="en-US" sz="2400" dirty="0"/>
           </a:p>
         </p:txBody>
       </p:sp>
@@ -12669,13 +13655,13 @@
               <a:buNone/>
             </a:pPr>
             <a:r>
-              <a:rPr lang="en-US" sz="2800" b="1" dirty="0">
+              <a:rPr lang="en-US" sz="2800" u="sng" dirty="0">
                 <a:solidFill>
                   <a:srgbClr val="1F6B5E"/>
                 </a:solidFill>
-                <a:latin typeface="Calibri" pitchFamily="34" charset="0"/>
-                <a:ea typeface="Calibri" pitchFamily="34" charset="-122"/>
-                <a:cs typeface="Calibri" pitchFamily="34" charset="-120"/>
+                <a:latin typeface="Arial Narrow" pitchFamily="34" charset="0"/>
+                <a:ea typeface="Arial Narrow" pitchFamily="34" charset="-122"/>
+                <a:cs typeface="Arial Narrow" pitchFamily="34" charset="-120"/>
               </a:rPr>
               <a:t>TABLEAU RÉGIONAL — NIVEAUX D'ALERTE</a:t>
             </a:r>
@@ -13297,7 +14283,7 @@
                           <a:ea typeface="Calibri" pitchFamily="34" charset="-122"/>
                           <a:cs typeface="Calibri" pitchFamily="34" charset="-120"/>
                         </a:rPr>
-                        <a:t>88.1</a:t>
+                        <a:t>89</a:t>
                       </a:r>
                       <a:endParaRPr lang="en-US" sz="1300" dirty="0">
                         <a:latin typeface="Calibri" charset="0"/>
@@ -13427,7 +14413,7 @@
                           <a:ea typeface="Calibri" pitchFamily="34" charset="-122"/>
                           <a:cs typeface="Calibri" pitchFamily="34" charset="-120"/>
                         </a:rPr>
-                        <a:t>4</a:t>
+                        <a:t>7</a:t>
                       </a:r>
                       <a:endParaRPr lang="en-US" sz="1300" dirty="0">
                         <a:latin typeface="Calibri" charset="0"/>
@@ -13757,7 +14743,7 @@
                           <a:ea typeface="Calibri" pitchFamily="34" charset="-122"/>
                           <a:cs typeface="Calibri" pitchFamily="34" charset="-120"/>
                         </a:rPr>
-                        <a:t>moyenne</a:t>
+                        <a:t>faible</a:t>
                       </a:r>
                       <a:endParaRPr lang="en-US" sz="1300" dirty="0">
                         <a:latin typeface="Calibri" charset="0"/>
@@ -13822,7 +14808,7 @@
                           <a:ea typeface="Calibri" pitchFamily="34" charset="-122"/>
                           <a:cs typeface="Calibri" pitchFamily="34" charset="-120"/>
                         </a:rPr>
-                        <a:t>12</a:t>
+                        <a:t>9</a:t>
                       </a:r>
                       <a:endParaRPr lang="en-US" sz="1300" dirty="0">
                         <a:latin typeface="Calibri" charset="0"/>
@@ -14217,7 +15203,7 @@
                           <a:ea typeface="Calibri" pitchFamily="34" charset="-122"/>
                           <a:cs typeface="Calibri" pitchFamily="34" charset="-120"/>
                         </a:rPr>
-                        <a:t>2</a:t>
+                        <a:t>1</a:t>
                       </a:r>
                       <a:endParaRPr lang="en-US" sz="1300" dirty="0">
                         <a:latin typeface="Calibri" charset="0"/>
@@ -14612,7 +15598,7 @@
                           <a:ea typeface="Calibri" pitchFamily="34" charset="-122"/>
                           <a:cs typeface="Calibri" pitchFamily="34" charset="-120"/>
                         </a:rPr>
-                        <a:t>1</a:t>
+                        <a:t>2</a:t>
                       </a:r>
                       <a:endParaRPr lang="en-US" sz="1300" dirty="0">
                         <a:latin typeface="Calibri" charset="0"/>
@@ -15007,7 +15993,7 @@
                           <a:ea typeface="Calibri" pitchFamily="34" charset="-122"/>
                           <a:cs typeface="Calibri" pitchFamily="34" charset="-120"/>
                         </a:rPr>
-                        <a:t>3</a:t>
+                        <a:t>5</a:t>
                       </a:r>
                       <a:endParaRPr lang="en-US" sz="1300" dirty="0">
                         <a:latin typeface="Calibri" charset="0"/>
@@ -15797,7 +16783,7 @@
                           <a:ea typeface="Calibri" pitchFamily="34" charset="-122"/>
                           <a:cs typeface="Calibri" pitchFamily="34" charset="-120"/>
                         </a:rPr>
-                        <a:t>5</a:t>
+                        <a:t>4</a:t>
                       </a:r>
                       <a:endParaRPr lang="en-US" sz="1300" dirty="0">
                         <a:latin typeface="Calibri" charset="0"/>
@@ -16192,7 +17178,7 @@
                           <a:ea typeface="Calibri" pitchFamily="34" charset="-122"/>
                           <a:cs typeface="Calibri" pitchFamily="34" charset="-120"/>
                         </a:rPr>
-                        <a:t>1</a:t>
+                        <a:t>0</a:t>
                       </a:r>
                       <a:endParaRPr lang="en-US" sz="1300" dirty="0">
                         <a:latin typeface="Calibri" charset="0"/>
@@ -16383,13 +17369,13 @@
                       <a:r>
                         <a:rPr lang="en-US" sz="1300" b="1" dirty="0">
                           <a:solidFill>
-                            <a:srgbClr val="1F2937"/>
+                            <a:srgbClr val="FFFFFF"/>
                           </a:solidFill>
                           <a:latin typeface="Calibri" pitchFamily="34" charset="0"/>
                           <a:ea typeface="Calibri" pitchFamily="34" charset="-122"/>
                           <a:cs typeface="Calibri" pitchFamily="34" charset="-120"/>
                         </a:rPr>
-                        <a:t>JAUNE</a:t>
+                        <a:t>ORANGE</a:t>
                       </a:r>
                       <a:endParaRPr lang="en-US" sz="1300" dirty="0">
                         <a:latin typeface="Calibri" charset="0"/>
@@ -16436,7 +17422,7 @@
                       <a:tailEnd type="none" w="med" len="med"/>
                     </a:lnB>
                     <a:solidFill>
-                      <a:srgbClr val="CA8A04"/>
+                      <a:srgbClr val="EA580C"/>
                     </a:solidFill>
                   </a:tcPr>
                 </a:tc>
@@ -16457,7 +17443,7 @@
                           <a:ea typeface="Calibri" pitchFamily="34" charset="-122"/>
                           <a:cs typeface="Calibri" pitchFamily="34" charset="-120"/>
                         </a:rPr>
-                        <a:t>31.3</a:t>
+                        <a:t>36.8</a:t>
                       </a:r>
                       <a:endParaRPr lang="en-US" sz="1300" dirty="0">
                         <a:latin typeface="Calibri" charset="0"/>
@@ -16652,7 +17638,7 @@
                           <a:ea typeface="Calibri" pitchFamily="34" charset="-122"/>
                           <a:cs typeface="Calibri" pitchFamily="34" charset="-120"/>
                         </a:rPr>
-                        <a:t>↓</a:t>
+                        <a:t>=</a:t>
                       </a:r>
                       <a:endParaRPr lang="en-US" sz="1300" dirty="0">
                         <a:latin typeface="Calibri" charset="0"/>
@@ -17028,17 +18014,17 @@
               <a:buNone/>
             </a:pPr>
             <a:r>
-              <a:rPr lang="en-US" sz="2200" b="1" dirty="0">
+              <a:rPr lang="en-US" sz="2400" dirty="0">
                 <a:solidFill>
                   <a:srgbClr val="FFFFFF"/>
                 </a:solidFill>
-                <a:latin typeface="Calibri" pitchFamily="34" charset="0"/>
-                <a:ea typeface="Calibri" pitchFamily="34" charset="-122"/>
-                <a:cs typeface="Calibri" pitchFamily="34" charset="-120"/>
+                <a:latin typeface="Arial Narrow" pitchFamily="34" charset="0"/>
+                <a:ea typeface="Arial Narrow" pitchFamily="34" charset="-122"/>
+                <a:cs typeface="Arial Narrow" pitchFamily="34" charset="-120"/>
               </a:rPr>
               <a:t>I</a:t>
             </a:r>
-            <a:endParaRPr lang="en-US" sz="2200" dirty="0"/>
+            <a:endParaRPr lang="en-US" sz="2400" dirty="0"/>
           </a:p>
         </p:txBody>
       </p:sp>
@@ -17067,13 +18053,13 @@
               <a:buNone/>
             </a:pPr>
             <a:r>
-              <a:rPr lang="en-US" sz="2800" b="1" dirty="0">
+              <a:rPr lang="en-US" sz="2800" u="sng" dirty="0">
                 <a:solidFill>
                   <a:srgbClr val="1F6B5E"/>
                 </a:solidFill>
-                <a:latin typeface="Calibri" pitchFamily="34" charset="0"/>
-                <a:ea typeface="Calibri" pitchFamily="34" charset="-122"/>
-                <a:cs typeface="Calibri" pitchFamily="34" charset="-120"/>
+                <a:latin typeface="Arial Narrow" pitchFamily="34" charset="0"/>
+                <a:ea typeface="Arial Narrow" pitchFamily="34" charset="-122"/>
+                <a:cs typeface="Arial Narrow" pitchFamily="34" charset="-120"/>
               </a:rPr>
               <a:t>Burkina Faso : situation au 21/10/26</a:t>
             </a:r>
@@ -17084,6 +18070,78 @@
       <p:sp>
         <p:nvSpPr>
           <p:cNvPr id="4" name="Shape 2"/>
+          <p:cNvSpPr/>
+          <p:nvPr/>
+        </p:nvSpPr>
+        <p:spPr>
+          <a:xfrm>
+            <a:off x="10881360" y="274320"/>
+            <a:ext cx="905256" cy="283464"/>
+          </a:xfrm>
+          <a:prstGeom prst="rect">
+            <a:avLst/>
+          </a:prstGeom>
+          <a:solidFill>
+            <a:srgbClr val="EF2B2D"/>
+          </a:solidFill>
+          <a:ln w="12700">
+            <a:solidFill>
+              <a:srgbClr val="EF2B2D"/>
+            </a:solidFill>
+            <a:prstDash val="solid"/>
+          </a:ln>
+        </p:spPr>
+      </p:sp>
+      <p:sp>
+        <p:nvSpPr>
+          <p:cNvPr id="5" name="Shape 3"/>
+          <p:cNvSpPr/>
+          <p:nvPr/>
+        </p:nvSpPr>
+        <p:spPr>
+          <a:xfrm>
+            <a:off x="10881360" y="557784"/>
+            <a:ext cx="905256" cy="283464"/>
+          </a:xfrm>
+          <a:prstGeom prst="rect">
+            <a:avLst/>
+          </a:prstGeom>
+          <a:solidFill>
+            <a:srgbClr val="009E49"/>
+          </a:solidFill>
+          <a:ln w="12700">
+            <a:solidFill>
+              <a:srgbClr val="009E49"/>
+            </a:solidFill>
+            <a:prstDash val="solid"/>
+          </a:ln>
+        </p:spPr>
+      </p:sp>
+      <p:sp>
+        <p:nvSpPr>
+          <p:cNvPr id="6" name="Shape 4"/>
+          <p:cNvSpPr/>
+          <p:nvPr/>
+        </p:nvSpPr>
+        <p:spPr>
+          <a:xfrm>
+            <a:off x="10881360" y="274320"/>
+            <a:ext cx="905256" cy="566928"/>
+          </a:xfrm>
+          <a:prstGeom prst="rect">
+            <a:avLst/>
+          </a:prstGeom>
+          <a:ln w="6350">
+            <a:solidFill>
+              <a:srgbClr val="1F2937"/>
+            </a:solidFill>
+            <a:prstDash val="solid"/>
+          </a:ln>
+        </p:spPr>
+      </p:sp>
+      <p:sp>
+        <p:nvSpPr>
+          <p:cNvPr id="7" name="Shape 5"/>
           <p:cNvSpPr/>
           <p:nvPr/>
         </p:nvSpPr>
@@ -17106,7 +18164,7 @@
       </p:sp>
       <p:sp>
         <p:nvSpPr>
-          <p:cNvPr id="5" name="Text 3"/>
+          <p:cNvPr id="8" name="Text 6"/>
           <p:cNvSpPr/>
           <p:nvPr/>
         </p:nvSpPr>
@@ -17147,7 +18205,7 @@
       </p:sp>
       <p:sp>
         <p:nvSpPr>
-          <p:cNvPr id="6" name="Text 4"/>
+          <p:cNvPr id="9" name="Text 7"/>
           <p:cNvSpPr/>
           <p:nvPr/>
         </p:nvSpPr>
@@ -17182,7 +18240,7 @@
                 <a:ea typeface="Calibri" pitchFamily="34" charset="-122"/>
                 <a:cs typeface="Calibri" pitchFamily="34" charset="-120"/>
               </a:rPr>
-              <a:t>Burkina Faso: la junte au pouvoir rétablit la peine de mort</a:t>
+              <a:t>« Le sentimentalisme, c’est fini » : au Burkina Faso, Ibrahim Traoré rétablit la peine de mort</a:t>
             </a:r>
             <a:endParaRPr lang="en-US" sz="1300" dirty="0"/>
           </a:p>
@@ -17202,7 +18260,7 @@
                 <a:ea typeface="Calibri" pitchFamily="34" charset="-122"/>
                 <a:cs typeface="Calibri" pitchFamily="34" charset="-120"/>
               </a:rPr>
-              <a:t>RFI Afrique · 21/10 03h UTC · niveau critique · Probable</a:t>
+              <a:t>Jeune Afrique · 21/10 09h UTC · niveau critique · Probable</a:t>
             </a:r>
             <a:endParaRPr lang="en-US" sz="1300" dirty="0"/>
           </a:p>
@@ -17223,7 +18281,7 @@
                 <a:ea typeface="Calibri" pitchFamily="34" charset="-122"/>
                 <a:cs typeface="Calibri" pitchFamily="34" charset="-120"/>
               </a:rPr>
-              <a:t>Burkina Faso : la peine de mort réintroduite dans le Code pénal</a:t>
+              <a:t>Burkina Faso : la peine de mort rétablie dans le nouveau Code pénal</a:t>
             </a:r>
             <a:endParaRPr lang="en-US" sz="1300" dirty="0"/>
           </a:p>
@@ -17243,7 +18301,7 @@
                 <a:ea typeface="Calibri" pitchFamily="34" charset="-122"/>
                 <a:cs typeface="Calibri" pitchFamily="34" charset="-120"/>
               </a:rPr>
-              <a:t>Guineematin.com · 20/10 22h UTC · niveau critique · Non confirmé</a:t>
+              <a:t>Maliactu · 21/10 08h UTC · niveau critique · Probable</a:t>
             </a:r>
             <a:endParaRPr lang="en-US" sz="1300" dirty="0"/>
           </a:p>
@@ -17264,7 +18322,7 @@
                 <a:ea typeface="Calibri" pitchFamily="34" charset="-122"/>
                 <a:cs typeface="Calibri" pitchFamily="34" charset="-120"/>
               </a:rPr>
-              <a:t>Sécurité alimentaire : le Burkina Faso développe 8 nouvelles variétés de riz grâce à la technologie nucléaire</a:t>
+              <a:t>Burkina Faso : le parlement vote le rétablissement de la peine de mort</a:t>
             </a:r>
             <a:endParaRPr lang="en-US" sz="1300" dirty="0"/>
           </a:p>
@@ -17284,7 +18342,7 @@
                 <a:ea typeface="Calibri" pitchFamily="34" charset="-122"/>
                 <a:cs typeface="Calibri" pitchFamily="34" charset="-120"/>
               </a:rPr>
-              <a:t>Actu Cameroun · 20/10 15h UTC · niveau élevé · Non confirmé</a:t>
+              <a:t>Africanews — Chaine panafricaine · 21/10 07h UTC · niveau critique · Probable</a:t>
             </a:r>
             <a:endParaRPr lang="en-US" sz="1300" dirty="0"/>
           </a:p>
@@ -17305,7 +18363,7 @@
                 <a:ea typeface="Calibri" pitchFamily="34" charset="-122"/>
                 <a:cs typeface="Calibri" pitchFamily="34" charset="-120"/>
               </a:rPr>
-              <a:t>Offensive agropastorale : le Premier ministre appelle les éleveurs à tirer pleinement profit des mesures d’accompagnement de l’État</a:t>
+              <a:t>Burkina Faso: la junte au pouvoir rétablit la peine de mort</a:t>
             </a:r>
             <a:endParaRPr lang="en-US" sz="1300" dirty="0"/>
           </a:p>
@@ -17325,7 +18383,7 @@
                 <a:ea typeface="Calibri" pitchFamily="34" charset="-122"/>
                 <a:cs typeface="Calibri" pitchFamily="34" charset="-120"/>
               </a:rPr>
-              <a:t>Gouvernement de transition Burkina Faso · 20/10 15h UTC · niveau élevé · Probable</a:t>
+              <a:t>RFI Afrique · 21/10 03h UTC · niveau critique · Confirmé</a:t>
             </a:r>
             <a:endParaRPr lang="en-US" sz="1300" dirty="0"/>
           </a:p>
@@ -17333,7 +18391,7 @@
       </p:sp>
       <p:sp>
         <p:nvSpPr>
-          <p:cNvPr id="7" name="Shape 5"/>
+          <p:cNvPr id="10" name="Shape 8"/>
           <p:cNvSpPr/>
           <p:nvPr/>
         </p:nvSpPr>
@@ -17358,7 +18416,7 @@
       </p:sp>
       <p:sp>
         <p:nvSpPr>
-          <p:cNvPr id="8" name="Text 6"/>
+          <p:cNvPr id="11" name="Text 9"/>
           <p:cNvSpPr/>
           <p:nvPr/>
         </p:nvSpPr>
@@ -17397,7 +18455,7 @@
       </p:sp>
       <p:sp>
         <p:nvSpPr>
-          <p:cNvPr id="9" name="Text 7"/>
+          <p:cNvPr id="12" name="Text 10"/>
           <p:cNvSpPr/>
           <p:nvPr/>
         </p:nvSpPr>
@@ -17432,7 +18490,7 @@
                 <a:ea typeface="Calibri" pitchFamily="34" charset="-122"/>
                 <a:cs typeface="Calibri" pitchFamily="34" charset="-120"/>
               </a:rPr>
-              <a:t>Niveau rouge (grave, 88.1/100), confiance moyenne.</a:t>
+              <a:t>Niveau rouge (grave, 89/100), confiance moyenne.</a:t>
             </a:r>
             <a:endParaRPr lang="en-US" sz="1200" dirty="0"/>
           </a:p>
@@ -17453,7 +18511,7 @@
                 <a:ea typeface="Calibri" pitchFamily="34" charset="-122"/>
                 <a:cs typeface="Calibri" pitchFamily="34" charset="-120"/>
               </a:rPr>
-              <a:t>Fondement : incident vérifié le plus récent : 113 jours ; 1 signal du jour.</a:t>
+              <a:t>Fondement : incident vérifié le plus récent : 114 jours ; 2 signaux du jour.</a:t>
             </a:r>
             <a:endParaRPr lang="en-US" sz="1200" dirty="0"/>
           </a:p>
@@ -17495,7 +18553,7 @@
                 <a:ea typeface="Calibri" pitchFamily="34" charset="-122"/>
                 <a:cs typeface="Calibri" pitchFamily="34" charset="-120"/>
               </a:rPr>
-              <a:t>4 fait(s) au-dessus du normal dans les 36 dernières heures.</a:t>
+              <a:t>7 fait(s) au-dessus du normal dans les 36 dernières heures.</a:t>
             </a:r>
             <a:endParaRPr lang="en-US" sz="1200" dirty="0"/>
           </a:p>
@@ -17503,7 +18561,7 @@
       </p:sp>
       <p:pic>
         <p:nvPicPr>
-          <p:cNvPr id="10" name="Image 0" descr="/home/runner/work/SentiqS/SentiqS/scripts/assets/grsci/logo-grsci.png">    </p:cNvPr>
+          <p:cNvPr id="13" name="Image 0" descr="/home/runner/work/SentiqS/SentiqS/scripts/assets/grsci/logo-grsci.png">    </p:cNvPr>
           <p:cNvPicPr>
             <a:picLocks noChangeAspect="1"/>
           </p:cNvPicPr>
@@ -17527,7 +18585,7 @@
       </p:pic>
       <p:sp>
         <p:nvSpPr>
-          <p:cNvPr id="11" name="Text 8"/>
+          <p:cNvPr id="14" name="Text 11"/>
           <p:cNvSpPr/>
           <p:nvPr/>
         </p:nvSpPr>
@@ -17696,7 +18754,7 @@
       </p:sp>
       <p:sp>
         <p:nvSpPr>
-          <p:cNvPr id="12" name="Text 9"/>
+          <p:cNvPr id="15" name="Text 12"/>
           <p:cNvSpPr/>
           <p:nvPr/>
         </p:nvSpPr>

</xml_diff>